<commit_message>
docs(pitch): 10-slide deck for 10-minute pitch with video placeholder and roadmap
Co-Authored-By: Claude Opus 5.5 <noreply@anthropic.com>
</commit_message>
<xml_diff>
--- a/docs/pitch/support-desk-pitch.pptx
+++ b/docs/pitch/support-desk-pitch.pptx
@@ -13,9 +13,11 @@
     <p:sldId id="261" r:id="rId7"/>
     <p:sldId id="262" r:id="rId8"/>
     <p:sldId id="263" r:id="rId9"/>
+    <p:sldId id="264" r:id="rId10"/>
+    <p:sldId id="265" r:id="rId11"/>
   </p:sldIdLst>
   <p:notesMasterIdLst>
-    <p:notesMasterId r:id="rId10"/>
+    <p:notesMasterId r:id="rId12"/>
   </p:notesMasterIdLst>
   <p:sldSz cx="9144000" cy="5143500"/>
   <p:notesSz cx="5143500" cy="9144000"/>
@@ -814,6 +816,94 @@
 </p:notes>
 </file>
 
+<file path=ppt/notesSlides/notesSlide10.xml><?xml version="1.0" encoding="utf-8"?>
+<p:notes xmlns:a="http://schemas.openxmlformats.org/drawingml/2006/main" xmlns:r="http://schemas.openxmlformats.org/officeDocument/2006/relationships" xmlns:p="http://schemas.openxmlformats.org/presentationml/2006/main">
+  <p:cSld>
+    <p:spTree>
+      <p:nvGrpSpPr>
+        <p:cNvPr id="1" name=""/>
+        <p:cNvGrpSpPr/>
+        <p:nvPr/>
+      </p:nvGrpSpPr>
+      <p:grpSpPr>
+        <a:xfrm>
+          <a:off x="0" y="0"/>
+          <a:ext cx="0" cy="0"/>
+          <a:chOff x="0" y="0"/>
+          <a:chExt cx="0" cy="0"/>
+        </a:xfrm>
+      </p:grpSpPr>
+      <p:sp>
+        <p:nvSpPr>
+          <p:cNvPr id="2" name="Slide Image Placeholder 1"/>
+          <p:cNvSpPr>
+            <a:spLocks noGrp="1" noRot="1" noChangeAspect="1"/>
+          </p:cNvSpPr>
+          <p:nvPr>
+            <p:ph type="sldImg"/>
+          </p:nvPr>
+        </p:nvSpPr>
+        <p:spPr/>
+      </p:sp>
+      <p:sp>
+        <p:nvSpPr>
+          <p:cNvPr id="3" name="Notes Placeholder 2"/>
+          <p:cNvSpPr>
+            <a:spLocks noGrp="1"/>
+          </p:cNvSpPr>
+          <p:nvPr>
+            <p:ph type="body" idx="1"/>
+          </p:nvPr>
+        </p:nvSpPr>
+        <p:spPr/>
+        <p:txBody>
+          <a:bodyPr/>
+          <a:lstStyle/>
+          <a:p>
+            <a:r>
+              <a:rPr lang="en-US" dirty="0"/>
+              <a:t>Закінчуємо наступним кроком і проханням, без «дякуємо за увагу».</a:t>
+            </a:r>
+            <a:endParaRPr lang="en-US" dirty="0"/>
+          </a:p>
+        </p:txBody>
+      </p:sp>
+      <p:sp>
+        <p:nvSpPr>
+          <p:cNvPr id="4" name="Slide Number Placeholder 3"/>
+          <p:cNvSpPr>
+            <a:spLocks noGrp="1"/>
+          </p:cNvSpPr>
+          <p:nvPr>
+            <p:ph type="sldNum" sz="quarter" idx="10"/>
+          </p:nvPr>
+        </p:nvSpPr>
+        <p:spPr/>
+        <p:txBody>
+          <a:bodyPr/>
+          <a:lstStyle/>
+          <a:p>
+            <a:fld id="{F7021451-1387-4CA6-816F-3879F97B5CBC}" type="slidenum">
+              <a:rPr lang="en-US"/>
+              <a:t>10</a:t>
+            </a:fld>
+            <a:endParaRPr lang="en-US"/>
+          </a:p>
+        </p:txBody>
+      </p:sp>
+    </p:spTree>
+    <p:extLst>
+      <p:ext uri="{BB962C8B-B14F-4D97-AF65-F5344CB8AC3E}">
+        <p14:creationId xmlns:p14="http://schemas.microsoft.com/office/powerpoint/2010/main" val="1024086991"/>
+      </p:ext>
+    </p:extLst>
+  </p:cSld>
+  <p:clrMapOvr>
+    <a:masterClrMapping/>
+  </p:clrMapOvr>
+</p:notes>
+</file>
+
 <file path=ppt/notesSlides/notesSlide2.xml><?xml version="1.0" encoding="utf-8"?>
 <p:notes xmlns:a="http://schemas.openxmlformats.org/drawingml/2006/main" xmlns:r="http://schemas.openxmlformats.org/officeDocument/2006/relationships" xmlns:p="http://schemas.openxmlformats.org/presentationml/2006/main">
   <p:cSld>
@@ -948,7 +1038,7 @@
           <a:p>
             <a:r>
               <a:rPr lang="en-US" dirty="0"/>
-              <a:t>Ключ: агент не має доступу до мутацій. Він пропонує одну з 4 дій, сервер сам перевіряє права, версії ресурсів і суму, а виконання можливе лише після підтвердження власника.</a:t>
+              <a:t>Клієнт це власник кафе або мережі, який користується SaaS (промокоди, каса, підписка). Він пише у підтримку компанії-розробника. Наш AI відповідає, діє з підтвердженням або передає людям.</a:t>
             </a:r>
             <a:endParaRPr lang="en-US" dirty="0"/>
           </a:p>
@@ -1036,7 +1126,7 @@
           <a:p>
             <a:r>
               <a:rPr lang="en-US" dirty="0"/>
-              <a:t>Демо в браузері: логін tenant_a. Показати докази під відповіддю, картку дії, підтвердження і результат. Для подвійного списання підкреслити: запит на повернення, а не повернення.</a:t>
+              <a:t>Ключ: агент не має доступу до мутацій. Він пропонує одну з 4 дій, сервер сам перевіряє права, версії ресурсів і суму, а виконання можливе лише після підтвердження власника.</a:t>
             </a:r>
             <a:endParaRPr lang="en-US" dirty="0"/>
           </a:p>
@@ -1212,7 +1302,7 @@
           <a:p>
             <a:r>
               <a:rPr lang="en-US" dirty="0"/>
-              <a:t>Формула: 1000 × 12 хв = 200 год. 25% залишаються людям = 50 год. Різниця 150 год ≈ 0,9 ставки, при 190 грн/год це ≈ 28,5 тис грн на місяць. Ще ефект для розробників: до них доходять тільки справжні баги зі структурованим тікетом.</a:t>
+              <a:t>Демо в браузері: логін tenant_a. Показати докази під відповіддю, картку дії, підтвердження і результат. Для подвійного списання підкреслити: запит на повернення, а не повернення.</a:t>
             </a:r>
             <a:endParaRPr lang="en-US" dirty="0"/>
           </a:p>
@@ -1388,7 +1478,7 @@
           <a:p>
             <a:r>
               <a:rPr lang="en-US" dirty="0"/>
-              <a:t>Закінчуємо наступним кроком, без «дякуємо за увагу».</a:t>
+              <a:t>Формула: 1000 × 12 хв = 200 год. 25% залишаються людям = 50 год. Різниця 150 год ≈ 0,9 ставки, при 190 грн/год це ≈ 28,5 тис грн на місяць. Ще ефект для розробників: до них доходять тільки справжні баги зі структурованим тікетом.</a:t>
             </a:r>
             <a:endParaRPr lang="en-US" dirty="0"/>
           </a:p>
@@ -1412,6 +1502,94 @@
             <a:fld id="{F7021451-1387-4CA6-816F-3879F97B5CBC}" type="slidenum">
               <a:rPr lang="en-US"/>
               <a:t>8</a:t>
+            </a:fld>
+            <a:endParaRPr lang="en-US"/>
+          </a:p>
+        </p:txBody>
+      </p:sp>
+    </p:spTree>
+    <p:extLst>
+      <p:ext uri="{BB962C8B-B14F-4D97-AF65-F5344CB8AC3E}">
+        <p14:creationId xmlns:p14="http://schemas.microsoft.com/office/powerpoint/2010/main" val="1024086991"/>
+      </p:ext>
+    </p:extLst>
+  </p:cSld>
+  <p:clrMapOvr>
+    <a:masterClrMapping/>
+  </p:clrMapOvr>
+</p:notes>
+</file>
+
+<file path=ppt/notesSlides/notesSlide9.xml><?xml version="1.0" encoding="utf-8"?>
+<p:notes xmlns:a="http://schemas.openxmlformats.org/drawingml/2006/main" xmlns:r="http://schemas.openxmlformats.org/officeDocument/2006/relationships" xmlns:p="http://schemas.openxmlformats.org/presentationml/2006/main">
+  <p:cSld>
+    <p:spTree>
+      <p:nvGrpSpPr>
+        <p:cNvPr id="1" name=""/>
+        <p:cNvGrpSpPr/>
+        <p:nvPr/>
+      </p:nvGrpSpPr>
+      <p:grpSpPr>
+        <a:xfrm>
+          <a:off x="0" y="0"/>
+          <a:ext cx="0" cy="0"/>
+          <a:chOff x="0" y="0"/>
+          <a:chExt cx="0" cy="0"/>
+        </a:xfrm>
+      </p:grpSpPr>
+      <p:sp>
+        <p:nvSpPr>
+          <p:cNvPr id="2" name="Slide Image Placeholder 1"/>
+          <p:cNvSpPr>
+            <a:spLocks noGrp="1" noRot="1" noChangeAspect="1"/>
+          </p:cNvSpPr>
+          <p:nvPr>
+            <p:ph type="sldImg"/>
+          </p:nvPr>
+        </p:nvSpPr>
+        <p:spPr/>
+      </p:sp>
+      <p:sp>
+        <p:nvSpPr>
+          <p:cNvPr id="3" name="Notes Placeholder 2"/>
+          <p:cNvSpPr>
+            <a:spLocks noGrp="1"/>
+          </p:cNvSpPr>
+          <p:nvPr>
+            <p:ph type="body" idx="1"/>
+          </p:nvPr>
+        </p:nvSpPr>
+        <p:spPr/>
+        <p:txBody>
+          <a:bodyPr/>
+          <a:lstStyle/>
+          <a:p>
+            <a:r>
+              <a:rPr lang="en-US" dirty="0"/>
+              <a:t>Усе це вже має основу в коді: корпус з полем judge, траси з POS_SYNC_FAILED, структуровані записи з тікетів.</a:t>
+            </a:r>
+            <a:endParaRPr lang="en-US" dirty="0"/>
+          </a:p>
+        </p:txBody>
+      </p:sp>
+      <p:sp>
+        <p:nvSpPr>
+          <p:cNvPr id="4" name="Slide Number Placeholder 3"/>
+          <p:cNvSpPr>
+            <a:spLocks noGrp="1"/>
+          </p:cNvSpPr>
+          <p:nvPr>
+            <p:ph type="sldNum" sz="quarter" idx="10"/>
+          </p:nvPr>
+        </p:nvSpPr>
+        <p:spPr/>
+        <p:txBody>
+          <a:bodyPr/>
+          <a:lstStyle/>
+          <a:p>
+            <a:fld id="{F7021451-1387-4CA6-816F-3879F97B5CBC}" type="slidenum">
+              <a:rPr lang="en-US"/>
+              <a:t>9</a:t>
             </a:fld>
             <a:endParaRPr lang="en-US"/>
           </a:p>
@@ -1886,6 +2064,201 @@
 </p:sld>
 </file>
 
+<file path=ppt/slides/slide10.xml><?xml version="1.0" encoding="utf-8"?>
+<p:sld xmlns:a="http://schemas.openxmlformats.org/drawingml/2006/main" xmlns:r="http://schemas.openxmlformats.org/officeDocument/2006/relationships" xmlns:p="http://schemas.openxmlformats.org/presentationml/2006/main">
+  <p:cSld name="Slide 10">
+    <p:bg>
+      <p:bgPr>
+        <a:solidFill>
+          <a:srgbClr val="1B2440"/>
+        </a:solidFill>
+      </p:bgPr>
+    </p:bg>
+    <p:spTree>
+      <p:nvGrpSpPr>
+        <p:cNvPr id="1" name=""/>
+        <p:cNvGrpSpPr/>
+        <p:nvPr/>
+      </p:nvGrpSpPr>
+      <p:grpSpPr>
+        <a:xfrm>
+          <a:off x="0" y="0"/>
+          <a:ext cx="0" cy="0"/>
+          <a:chOff x="0" y="0"/>
+          <a:chExt cx="0" cy="0"/>
+        </a:xfrm>
+      </p:grpSpPr>
+      <p:sp>
+        <p:nvSpPr>
+          <p:cNvPr id="2" name="Text 0"/>
+          <p:cNvSpPr/>
+          <p:nvPr/>
+        </p:nvSpPr>
+        <p:spPr>
+          <a:xfrm>
+            <a:off x="457200" y="320040"/>
+            <a:ext cx="8229600" cy="640080"/>
+          </a:xfrm>
+          <a:prstGeom prst="rect">
+            <a:avLst/>
+          </a:prstGeom>
+          <a:noFill/>
+          <a:ln/>
+        </p:spPr>
+        <p:txBody>
+          <a:bodyPr wrap="square" lIns="0" tIns="0" rIns="0" bIns="0" rtlCol="0" anchor="ctr"/>
+          <a:lstStyle/>
+          <a:p>
+            <a:pPr indent="0" marL="0">
+              <a:buNone/>
+            </a:pPr>
+            <a:r>
+              <a:rPr lang="en-US" sz="3000" b="1" dirty="0">
+                <a:solidFill>
+                  <a:srgbClr val="FFFFFF"/>
+                </a:solidFill>
+                <a:latin typeface="Cambria" pitchFamily="34" charset="0"/>
+                <a:ea typeface="Cambria" pitchFamily="34" charset="-122"/>
+                <a:cs typeface="Cambria" pitchFamily="34" charset="-120"/>
+              </a:rPr>
+              <a:t>Наступний крок</a:t>
+            </a:r>
+            <a:endParaRPr lang="en-US" sz="3000" dirty="0"/>
+          </a:p>
+        </p:txBody>
+      </p:sp>
+      <p:sp>
+        <p:nvSpPr>
+          <p:cNvPr id="3" name="Text 1"/>
+          <p:cNvSpPr/>
+          <p:nvPr/>
+        </p:nvSpPr>
+        <p:spPr>
+          <a:xfrm>
+            <a:off x="457200" y="1371600"/>
+            <a:ext cx="8229600" cy="914400"/>
+          </a:xfrm>
+          <a:prstGeom prst="rect">
+            <a:avLst/>
+          </a:prstGeom>
+          <a:noFill/>
+          <a:ln/>
+        </p:spPr>
+        <p:txBody>
+          <a:bodyPr wrap="square" lIns="0" tIns="0" rIns="0" bIns="0" rtlCol="0" anchor="ctr"/>
+          <a:lstStyle/>
+          <a:p>
+            <a:pPr indent="0" marL="0">
+              <a:buNone/>
+            </a:pPr>
+            <a:r>
+              <a:rPr lang="en-US" sz="2800" b="1" dirty="0">
+                <a:solidFill>
+                  <a:srgbClr val="F2A541"/>
+                </a:solidFill>
+                <a:latin typeface="Cambria" pitchFamily="34" charset="0"/>
+                <a:ea typeface="Cambria" pitchFamily="34" charset="-122"/>
+                <a:cs typeface="Cambria" pitchFamily="34" charset="-120"/>
+              </a:rPr>
+              <a:t>Пілот на реальній тікет-системі одного SaaS для закладів</a:t>
+            </a:r>
+            <a:endParaRPr lang="en-US" sz="2800" dirty="0"/>
+          </a:p>
+        </p:txBody>
+      </p:sp>
+      <p:sp>
+        <p:nvSpPr>
+          <p:cNvPr id="4" name="Text 2"/>
+          <p:cNvSpPr/>
+          <p:nvPr/>
+        </p:nvSpPr>
+        <p:spPr>
+          <a:xfrm>
+            <a:off x="457200" y="2468880"/>
+            <a:ext cx="8229600" cy="1828800"/>
+          </a:xfrm>
+          <a:prstGeom prst="rect">
+            <a:avLst/>
+          </a:prstGeom>
+          <a:noFill/>
+          <a:ln/>
+        </p:spPr>
+        <p:txBody>
+          <a:bodyPr wrap="square" lIns="0" tIns="0" rIns="0" bIns="0" rtlCol="0" anchor="t"/>
+          <a:lstStyle/>
+          <a:p>
+            <a:pPr marL="342900" indent="-342900">
+              <a:spcAft>
+                <a:spcPts val="800"/>
+              </a:spcAft>
+              <a:buSzPct val="100000"/>
+              <a:buChar char="•"/>
+            </a:pPr>
+            <a:r>
+              <a:rPr lang="en-US" sz="1600" dirty="0">
+                <a:solidFill>
+                  <a:srgbClr val="D5DBE8"/>
+                </a:solidFill>
+                <a:latin typeface="Calibri" pitchFamily="34" charset="0"/>
+                <a:ea typeface="Calibri" pitchFamily="34" charset="-122"/>
+                <a:cs typeface="Calibri" pitchFamily="34" charset="-120"/>
+              </a:rPr>
+              <a:t>2 тижні: підключити історію тікетів і документацію, порахувати реальну частку автоматизації</a:t>
+            </a:r>
+            <a:endParaRPr lang="en-US" sz="1600" dirty="0"/>
+          </a:p>
+          <a:p>
+            <a:pPr marL="342900" indent="-342900">
+              <a:spcAft>
+                <a:spcPts val="800"/>
+              </a:spcAft>
+              <a:buSzPct val="100000"/>
+              <a:buChar char="•"/>
+            </a:pPr>
+            <a:r>
+              <a:rPr lang="en-US" sz="1600" dirty="0">
+                <a:solidFill>
+                  <a:srgbClr val="D5DBE8"/>
+                </a:solidFill>
+                <a:latin typeface="Calibri" pitchFamily="34" charset="0"/>
+                <a:ea typeface="Calibri" pitchFamily="34" charset="-122"/>
+                <a:cs typeface="Calibri" pitchFamily="34" charset="-120"/>
+              </a:rPr>
+              <a:t>Шукаємо: SaaS-партнера з тікетами та ментора з продукту</a:t>
+            </a:r>
+            <a:endParaRPr lang="en-US" sz="1600" dirty="0"/>
+          </a:p>
+          <a:p>
+            <a:pPr marL="342900" indent="-342900">
+              <a:spcAft>
+                <a:spcPts val="800"/>
+              </a:spcAft>
+              <a:buSzPct val="100000"/>
+              <a:buChar char="•"/>
+            </a:pPr>
+            <a:r>
+              <a:rPr lang="en-US" sz="1600" dirty="0">
+                <a:solidFill>
+                  <a:srgbClr val="D5DBE8"/>
+                </a:solidFill>
+                <a:latin typeface="Calibri" pitchFamily="34" charset="0"/>
+                <a:ea typeface="Calibri" pitchFamily="34" charset="-122"/>
+                <a:cs typeface="Calibri" pitchFamily="34" charset="-120"/>
+              </a:rPr>
+              <a:t>Код: github.com/Ansandr/hackday-lviv-2026-mvp</a:t>
+            </a:r>
+            <a:endParaRPr lang="en-US" sz="1600" dirty="0"/>
+          </a:p>
+        </p:txBody>
+      </p:sp>
+    </p:spTree>
+  </p:cSld>
+  <p:clrMapOvr>
+    <a:masterClrMapping/>
+  </p:clrMapOvr>
+</p:sld>
+</file>
+
 <file path=ppt/slides/slide2.xml><?xml version="1.0" encoding="utf-8"?>
 <p:sld xmlns:a="http://schemas.openxmlformats.org/drawingml/2006/main" xmlns:r="http://schemas.openxmlformats.org/officeDocument/2006/relationships" xmlns:p="http://schemas.openxmlformats.org/presentationml/2006/main">
   <p:cSld name="Slide 2">
@@ -2590,7 +2963,7 @@
                 <a:ea typeface="Cambria" pitchFamily="34" charset="-122"/>
                 <a:cs typeface="Cambria" pitchFamily="34" charset="-120"/>
               </a:rPr>
-              <a:t>Рішення: від звернення до перевіреної дії</a:t>
+              <a:t>Рішення: AI-шар між власником закладу і розробниками</a:t>
             </a:r>
             <a:endParaRPr lang="en-US" sz="3000" dirty="0"/>
           </a:p>
@@ -2604,12 +2977,12 @@
         </p:nvSpPr>
         <p:spPr>
           <a:xfrm>
-            <a:off x="457200" y="1417320"/>
-            <a:ext cx="1261872" cy="1828800"/>
+            <a:off x="457200" y="1325880"/>
+            <a:ext cx="2606040" cy="2377440"/>
           </a:xfrm>
           <a:prstGeom prst="roundRect">
             <a:avLst>
-              <a:gd name="adj" fmla="val 8696"/>
+              <a:gd name="adj" fmla="val 4615"/>
             </a:avLst>
           </a:prstGeom>
           <a:solidFill>
@@ -2633,14 +3006,14 @@
         </p:nvSpPr>
         <p:spPr>
           <a:xfrm>
-            <a:off x="859536" y="1554480"/>
-            <a:ext cx="457200" cy="457200"/>
+            <a:off x="685800" y="1508760"/>
+            <a:ext cx="411480" cy="411480"/>
           </a:xfrm>
           <a:prstGeom prst="ellipse">
             <a:avLst/>
           </a:prstGeom>
           <a:solidFill>
-            <a:srgbClr val="D7DEEA"/>
+            <a:srgbClr val="2A9D8F"/>
           </a:solidFill>
           <a:ln/>
         </p:spPr>
@@ -2653,34 +3026,34 @@
         </p:nvSpPr>
         <p:spPr>
           <a:xfrm>
-            <a:off x="859536" y="1554480"/>
-            <a:ext cx="457200" cy="457200"/>
-          </a:xfrm>
-          <a:prstGeom prst="rect">
-            <a:avLst/>
-          </a:prstGeom>
-          <a:noFill/>
-          <a:ln/>
-        </p:spPr>
-        <p:txBody>
-          <a:bodyPr wrap="square" lIns="0" tIns="0" rIns="0" bIns="0" rtlCol="0" anchor="ctr"/>
-          <a:lstStyle/>
-          <a:p>
-            <a:pPr algn="ctr" indent="0" marL="0">
-              <a:buNone/>
-            </a:pPr>
-            <a:r>
-              <a:rPr lang="en-US" sz="1600" b="1" dirty="0">
+            <a:off x="685800" y="2057400"/>
+            <a:ext cx="2194560" cy="411480"/>
+          </a:xfrm>
+          <a:prstGeom prst="rect">
+            <a:avLst/>
+          </a:prstGeom>
+          <a:noFill/>
+          <a:ln/>
+        </p:spPr>
+        <p:txBody>
+          <a:bodyPr wrap="square" lIns="0" tIns="0" rIns="0" bIns="0" rtlCol="0" anchor="ctr"/>
+          <a:lstStyle/>
+          <a:p>
+            <a:pPr indent="0" marL="0">
+              <a:buNone/>
+            </a:pPr>
+            <a:r>
+              <a:rPr lang="en-US" sz="2000" b="1" dirty="0">
                 <a:solidFill>
                   <a:srgbClr val="1B2440"/>
                 </a:solidFill>
-                <a:latin typeface="Calibri" pitchFamily="34" charset="0"/>
-                <a:ea typeface="Calibri" pitchFamily="34" charset="-122"/>
-                <a:cs typeface="Calibri" pitchFamily="34" charset="-120"/>
-              </a:rPr>
-              <a:t>1</a:t>
-            </a:r>
-            <a:endParaRPr lang="en-US" sz="1600" dirty="0"/>
+                <a:latin typeface="Cambria" pitchFamily="34" charset="0"/>
+                <a:ea typeface="Cambria" pitchFamily="34" charset="-122"/>
+                <a:cs typeface="Cambria" pitchFamily="34" charset="-120"/>
+              </a:rPr>
+              <a:t>Відповідає</a:t>
+            </a:r>
+            <a:endParaRPr lang="en-US" sz="2000" dirty="0"/>
           </a:p>
         </p:txBody>
       </p:sp>
@@ -2692,63 +3065,24 @@
         </p:nvSpPr>
         <p:spPr>
           <a:xfrm>
-            <a:off x="530352" y="2103120"/>
-            <a:ext cx="1115568" cy="365760"/>
-          </a:xfrm>
-          <a:prstGeom prst="rect">
-            <a:avLst/>
-          </a:prstGeom>
-          <a:noFill/>
-          <a:ln/>
-        </p:spPr>
-        <p:txBody>
-          <a:bodyPr wrap="square" lIns="0" tIns="0" rIns="0" bIns="0" rtlCol="0" anchor="ctr"/>
-          <a:lstStyle/>
-          <a:p>
-            <a:pPr algn="ctr" indent="0" marL="0">
-              <a:buNone/>
-            </a:pPr>
-            <a:r>
-              <a:rPr lang="en-US" sz="1150" b="1" dirty="0">
-                <a:solidFill>
-                  <a:srgbClr val="1B2440"/>
-                </a:solidFill>
-                <a:latin typeface="Calibri" pitchFamily="34" charset="0"/>
-                <a:ea typeface="Calibri" pitchFamily="34" charset="-122"/>
-                <a:cs typeface="Calibri" pitchFamily="34" charset="-120"/>
-              </a:rPr>
-              <a:t>Звернення</a:t>
-            </a:r>
-            <a:endParaRPr lang="en-US" sz="1150" dirty="0"/>
-          </a:p>
-        </p:txBody>
-      </p:sp>
-      <p:sp>
-        <p:nvSpPr>
-          <p:cNvPr id="7" name="Text 5"/>
-          <p:cNvSpPr/>
-          <p:nvPr/>
-        </p:nvSpPr>
-        <p:spPr>
-          <a:xfrm>
-            <a:off x="530352" y="2468880"/>
-            <a:ext cx="1115568" cy="685800"/>
-          </a:xfrm>
-          <a:prstGeom prst="rect">
-            <a:avLst/>
-          </a:prstGeom>
-          <a:noFill/>
-          <a:ln/>
-        </p:spPr>
-        <p:txBody>
-          <a:bodyPr wrap="square" lIns="0" tIns="0" rIns="0" bIns="0" rtlCol="0" anchor="ctr"/>
-          <a:lstStyle/>
-          <a:p>
-            <a:pPr algn="ctr" indent="0" marL="0">
-              <a:buNone/>
-            </a:pPr>
-            <a:r>
-              <a:rPr lang="en-US" sz="1050" dirty="0">
+            <a:off x="685800" y="2514600"/>
+            <a:ext cx="2194560" cy="1097280"/>
+          </a:xfrm>
+          <a:prstGeom prst="rect">
+            <a:avLst/>
+          </a:prstGeom>
+          <a:noFill/>
+          <a:ln/>
+        </p:spPr>
+        <p:txBody>
+          <a:bodyPr wrap="square" lIns="0" tIns="0" rIns="0" bIns="0" rtlCol="0" anchor="t"/>
+          <a:lstStyle/>
+          <a:p>
+            <a:pPr indent="0" marL="0">
+              <a:buNone/>
+            </a:pPr>
+            <a:r>
+              <a:rPr lang="en-US" sz="1250" dirty="0">
                 <a:solidFill>
                   <a:srgbClr val="6B7280"/>
                 </a:solidFill>
@@ -2756,26 +3090,26 @@
                 <a:ea typeface="Calibri" pitchFamily="34" charset="-122"/>
                 <a:cs typeface="Calibri" pitchFamily="34" charset="-120"/>
               </a:rPr>
-              <a:t>власник пише як звик</a:t>
-            </a:r>
-            <a:endParaRPr lang="en-US" sz="1050" dirty="0"/>
-          </a:p>
-        </p:txBody>
-      </p:sp>
-      <p:sp>
-        <p:nvSpPr>
-          <p:cNvPr id="8" name="Shape 6"/>
-          <p:cNvSpPr/>
-          <p:nvPr/>
-        </p:nvSpPr>
-        <p:spPr>
-          <a:xfrm>
-            <a:off x="1856232" y="1417320"/>
-            <a:ext cx="1261872" cy="1828800"/>
+              <a:t>питання «як зробити» закриває з бази знань і показує джерело</a:t>
+            </a:r>
+            <a:endParaRPr lang="en-US" sz="1250" dirty="0"/>
+          </a:p>
+        </p:txBody>
+      </p:sp>
+      <p:sp>
+        <p:nvSpPr>
+          <p:cNvPr id="7" name="Shape 5"/>
+          <p:cNvSpPr/>
+          <p:nvPr/>
+        </p:nvSpPr>
+        <p:spPr>
+          <a:xfrm>
+            <a:off x="3246120" y="1325880"/>
+            <a:ext cx="2606040" cy="2377440"/>
           </a:xfrm>
           <a:prstGeom prst="roundRect">
             <a:avLst>
-              <a:gd name="adj" fmla="val 8696"/>
+              <a:gd name="adj" fmla="val 4615"/>
             </a:avLst>
           </a:prstGeom>
           <a:solidFill>
@@ -2793,128 +3127,89 @@
       </p:sp>
       <p:sp>
         <p:nvSpPr>
-          <p:cNvPr id="9" name="Shape 7"/>
-          <p:cNvSpPr/>
-          <p:nvPr/>
-        </p:nvSpPr>
-        <p:spPr>
-          <a:xfrm>
-            <a:off x="2258568" y="1554480"/>
-            <a:ext cx="457200" cy="457200"/>
+          <p:cNvPr id="8" name="Shape 6"/>
+          <p:cNvSpPr/>
+          <p:nvPr/>
+        </p:nvSpPr>
+        <p:spPr>
+          <a:xfrm>
+            <a:off x="3474720" y="1508760"/>
+            <a:ext cx="411480" cy="411480"/>
           </a:xfrm>
           <a:prstGeom prst="ellipse">
             <a:avLst/>
           </a:prstGeom>
           <a:solidFill>
-            <a:srgbClr val="D7DEEA"/>
+            <a:srgbClr val="F2A541"/>
           </a:solidFill>
           <a:ln/>
         </p:spPr>
       </p:sp>
       <p:sp>
         <p:nvSpPr>
+          <p:cNvPr id="9" name="Text 7"/>
+          <p:cNvSpPr/>
+          <p:nvPr/>
+        </p:nvSpPr>
+        <p:spPr>
+          <a:xfrm>
+            <a:off x="3474720" y="2057400"/>
+            <a:ext cx="2194560" cy="411480"/>
+          </a:xfrm>
+          <a:prstGeom prst="rect">
+            <a:avLst/>
+          </a:prstGeom>
+          <a:noFill/>
+          <a:ln/>
+        </p:spPr>
+        <p:txBody>
+          <a:bodyPr wrap="square" lIns="0" tIns="0" rIns="0" bIns="0" rtlCol="0" anchor="ctr"/>
+          <a:lstStyle/>
+          <a:p>
+            <a:pPr indent="0" marL="0">
+              <a:buNone/>
+            </a:pPr>
+            <a:r>
+              <a:rPr lang="en-US" sz="2000" b="1" dirty="0">
+                <a:solidFill>
+                  <a:srgbClr val="1B2440"/>
+                </a:solidFill>
+                <a:latin typeface="Cambria" pitchFamily="34" charset="0"/>
+                <a:ea typeface="Cambria" pitchFamily="34" charset="-122"/>
+                <a:cs typeface="Cambria" pitchFamily="34" charset="-120"/>
+              </a:rPr>
+              <a:t>Діє</a:t>
+            </a:r>
+            <a:endParaRPr lang="en-US" sz="2000" dirty="0"/>
+          </a:p>
+        </p:txBody>
+      </p:sp>
+      <p:sp>
+        <p:nvSpPr>
           <p:cNvPr id="10" name="Text 8"/>
           <p:cNvSpPr/>
           <p:nvPr/>
         </p:nvSpPr>
         <p:spPr>
           <a:xfrm>
-            <a:off x="2258568" y="1554480"/>
-            <a:ext cx="457200" cy="457200"/>
-          </a:xfrm>
-          <a:prstGeom prst="rect">
-            <a:avLst/>
-          </a:prstGeom>
-          <a:noFill/>
-          <a:ln/>
-        </p:spPr>
-        <p:txBody>
-          <a:bodyPr wrap="square" lIns="0" tIns="0" rIns="0" bIns="0" rtlCol="0" anchor="ctr"/>
-          <a:lstStyle/>
-          <a:p>
-            <a:pPr algn="ctr" indent="0" marL="0">
-              <a:buNone/>
-            </a:pPr>
-            <a:r>
-              <a:rPr lang="en-US" sz="1600" b="1" dirty="0">
-                <a:solidFill>
-                  <a:srgbClr val="1B2440"/>
-                </a:solidFill>
-                <a:latin typeface="Calibri" pitchFamily="34" charset="0"/>
-                <a:ea typeface="Calibri" pitchFamily="34" charset="-122"/>
-                <a:cs typeface="Calibri" pitchFamily="34" charset="-120"/>
-              </a:rPr>
-              <a:t>2</a:t>
-            </a:r>
-            <a:endParaRPr lang="en-US" sz="1600" dirty="0"/>
-          </a:p>
-        </p:txBody>
-      </p:sp>
-      <p:sp>
-        <p:nvSpPr>
-          <p:cNvPr id="11" name="Text 9"/>
-          <p:cNvSpPr/>
-          <p:nvPr/>
-        </p:nvSpPr>
-        <p:spPr>
-          <a:xfrm>
-            <a:off x="1929384" y="2103120"/>
-            <a:ext cx="1115568" cy="365760"/>
-          </a:xfrm>
-          <a:prstGeom prst="rect">
-            <a:avLst/>
-          </a:prstGeom>
-          <a:noFill/>
-          <a:ln/>
-        </p:spPr>
-        <p:txBody>
-          <a:bodyPr wrap="square" lIns="0" tIns="0" rIns="0" bIns="0" rtlCol="0" anchor="ctr"/>
-          <a:lstStyle/>
-          <a:p>
-            <a:pPr algn="ctr" indent="0" marL="0">
-              <a:buNone/>
-            </a:pPr>
-            <a:r>
-              <a:rPr lang="en-US" sz="1150" b="1" dirty="0">
-                <a:solidFill>
-                  <a:srgbClr val="1B2440"/>
-                </a:solidFill>
-                <a:latin typeface="Calibri" pitchFamily="34" charset="0"/>
-                <a:ea typeface="Calibri" pitchFamily="34" charset="-122"/>
-                <a:cs typeface="Calibri" pitchFamily="34" charset="-120"/>
-              </a:rPr>
-              <a:t>Gemma</a:t>
-            </a:r>
-            <a:endParaRPr lang="en-US" sz="1150" dirty="0"/>
-          </a:p>
-        </p:txBody>
-      </p:sp>
-      <p:sp>
-        <p:nvSpPr>
-          <p:cNvPr id="12" name="Text 10"/>
-          <p:cNvSpPr/>
-          <p:nvPr/>
-        </p:nvSpPr>
-        <p:spPr>
-          <a:xfrm>
-            <a:off x="1929384" y="2468880"/>
-            <a:ext cx="1115568" cy="685800"/>
-          </a:xfrm>
-          <a:prstGeom prst="rect">
-            <a:avLst/>
-          </a:prstGeom>
-          <a:noFill/>
-          <a:ln/>
-        </p:spPr>
-        <p:txBody>
-          <a:bodyPr wrap="square" lIns="0" tIns="0" rIns="0" bIns="0" rtlCol="0" anchor="ctr"/>
-          <a:lstStyle/>
-          <a:p>
-            <a:pPr algn="ctr" indent="0" marL="0">
-              <a:buNone/>
-            </a:pPr>
-            <a:r>
-              <a:rPr lang="en-US" sz="1050" dirty="0">
+            <a:off x="3474720" y="2514600"/>
+            <a:ext cx="2194560" cy="1097280"/>
+          </a:xfrm>
+          <a:prstGeom prst="rect">
+            <a:avLst/>
+          </a:prstGeom>
+          <a:noFill/>
+          <a:ln/>
+        </p:spPr>
+        <p:txBody>
+          <a:bodyPr wrap="square" lIns="0" tIns="0" rIns="0" bIns="0" rtlCol="0" anchor="t"/>
+          <a:lstStyle/>
+          <a:p>
+            <a:pPr indent="0" marL="0">
+              <a:buNone/>
+            </a:pPr>
+            <a:r>
+              <a:rPr lang="en-US" sz="1250" dirty="0">
                 <a:solidFill>
                   <a:srgbClr val="6B7280"/>
                 </a:solidFill>
@@ -2922,26 +3217,26 @@
                 <a:ea typeface="Calibri" pitchFamily="34" charset="-122"/>
                 <a:cs typeface="Calibri" pitchFamily="34" charset="-120"/>
               </a:rPr>
-              <a:t>розуміє інтент, викликає інструменти</a:t>
-            </a:r>
-            <a:endParaRPr lang="en-US" sz="1050" dirty="0"/>
-          </a:p>
-        </p:txBody>
-      </p:sp>
-      <p:sp>
-        <p:nvSpPr>
-          <p:cNvPr id="13" name="Shape 11"/>
-          <p:cNvSpPr/>
-          <p:nvPr/>
-        </p:nvSpPr>
-        <p:spPr>
-          <a:xfrm>
-            <a:off x="3255264" y="1417320"/>
-            <a:ext cx="1261872" cy="1828800"/>
+              <a:t>знаходить причину в логах і пропонує одну з 4 дій; виконує лише після підтвердження власника</a:t>
+            </a:r>
+            <a:endParaRPr lang="en-US" sz="1250" dirty="0"/>
+          </a:p>
+        </p:txBody>
+      </p:sp>
+      <p:sp>
+        <p:nvSpPr>
+          <p:cNvPr id="11" name="Shape 9"/>
+          <p:cNvSpPr/>
+          <p:nvPr/>
+        </p:nvSpPr>
+        <p:spPr>
+          <a:xfrm>
+            <a:off x="6035040" y="1325880"/>
+            <a:ext cx="2606040" cy="2377440"/>
           </a:xfrm>
           <a:prstGeom prst="roundRect">
             <a:avLst>
-              <a:gd name="adj" fmla="val 8696"/>
+              <a:gd name="adj" fmla="val 4615"/>
             </a:avLst>
           </a:prstGeom>
           <a:solidFill>
@@ -2959,50 +3254,128 @@
       </p:sp>
       <p:sp>
         <p:nvSpPr>
-          <p:cNvPr id="14" name="Shape 12"/>
-          <p:cNvSpPr/>
-          <p:nvPr/>
-        </p:nvSpPr>
-        <p:spPr>
-          <a:xfrm>
-            <a:off x="3657600" y="1554480"/>
-            <a:ext cx="457200" cy="457200"/>
+          <p:cNvPr id="12" name="Shape 10"/>
+          <p:cNvSpPr/>
+          <p:nvPr/>
+        </p:nvSpPr>
+        <p:spPr>
+          <a:xfrm>
+            <a:off x="6263640" y="1508760"/>
+            <a:ext cx="411480" cy="411480"/>
           </a:xfrm>
           <a:prstGeom prst="ellipse">
             <a:avLst/>
           </a:prstGeom>
           <a:solidFill>
-            <a:srgbClr val="D7DEEA"/>
+            <a:srgbClr val="C8553D"/>
           </a:solidFill>
           <a:ln/>
         </p:spPr>
       </p:sp>
       <p:sp>
         <p:nvSpPr>
+          <p:cNvPr id="13" name="Text 11"/>
+          <p:cNvSpPr/>
+          <p:nvPr/>
+        </p:nvSpPr>
+        <p:spPr>
+          <a:xfrm>
+            <a:off x="6263640" y="2057400"/>
+            <a:ext cx="2194560" cy="411480"/>
+          </a:xfrm>
+          <a:prstGeom prst="rect">
+            <a:avLst/>
+          </a:prstGeom>
+          <a:noFill/>
+          <a:ln/>
+        </p:spPr>
+        <p:txBody>
+          <a:bodyPr wrap="square" lIns="0" tIns="0" rIns="0" bIns="0" rtlCol="0" anchor="ctr"/>
+          <a:lstStyle/>
+          <a:p>
+            <a:pPr indent="0" marL="0">
+              <a:buNone/>
+            </a:pPr>
+            <a:r>
+              <a:rPr lang="en-US" sz="2000" b="1" dirty="0">
+                <a:solidFill>
+                  <a:srgbClr val="1B2440"/>
+                </a:solidFill>
+                <a:latin typeface="Cambria" pitchFamily="34" charset="0"/>
+                <a:ea typeface="Cambria" pitchFamily="34" charset="-122"/>
+                <a:cs typeface="Cambria" pitchFamily="34" charset="-120"/>
+              </a:rPr>
+              <a:t>Ескалує</a:t>
+            </a:r>
+            <a:endParaRPr lang="en-US" sz="2000" dirty="0"/>
+          </a:p>
+        </p:txBody>
+      </p:sp>
+      <p:sp>
+        <p:nvSpPr>
+          <p:cNvPr id="14" name="Text 12"/>
+          <p:cNvSpPr/>
+          <p:nvPr/>
+        </p:nvSpPr>
+        <p:spPr>
+          <a:xfrm>
+            <a:off x="6263640" y="2514600"/>
+            <a:ext cx="2194560" cy="1097280"/>
+          </a:xfrm>
+          <a:prstGeom prst="rect">
+            <a:avLst/>
+          </a:prstGeom>
+          <a:noFill/>
+          <a:ln/>
+        </p:spPr>
+        <p:txBody>
+          <a:bodyPr wrap="square" lIns="0" tIns="0" rIns="0" bIns="0" rtlCol="0" anchor="t"/>
+          <a:lstStyle/>
+          <a:p>
+            <a:pPr indent="0" marL="0">
+              <a:buNone/>
+            </a:pPr>
+            <a:r>
+              <a:rPr lang="en-US" sz="1250" dirty="0">
+                <a:solidFill>
+                  <a:srgbClr val="6B7280"/>
+                </a:solidFill>
+                <a:latin typeface="Calibri" pitchFamily="34" charset="0"/>
+                <a:ea typeface="Calibri" pitchFamily="34" charset="-122"/>
+                <a:cs typeface="Calibri" pitchFamily="34" charset="-120"/>
+              </a:rPr>
+              <a:t>до людей і розробників доходять лише справжні баги та гроші, що потребують рішення</a:t>
+            </a:r>
+            <a:endParaRPr lang="en-US" sz="1250" dirty="0"/>
+          </a:p>
+        </p:txBody>
+      </p:sp>
+      <p:sp>
+        <p:nvSpPr>
           <p:cNvPr id="15" name="Text 13"/>
           <p:cNvSpPr/>
           <p:nvPr/>
         </p:nvSpPr>
         <p:spPr>
           <a:xfrm>
-            <a:off x="3657600" y="1554480"/>
-            <a:ext cx="457200" cy="457200"/>
-          </a:xfrm>
-          <a:prstGeom prst="rect">
-            <a:avLst/>
-          </a:prstGeom>
-          <a:noFill/>
-          <a:ln/>
-        </p:spPr>
-        <p:txBody>
-          <a:bodyPr wrap="square" lIns="0" tIns="0" rIns="0" bIns="0" rtlCol="0" anchor="ctr"/>
-          <a:lstStyle/>
-          <a:p>
-            <a:pPr algn="ctr" indent="0" marL="0">
-              <a:buNone/>
-            </a:pPr>
-            <a:r>
-              <a:rPr lang="en-US" sz="1600" b="1" dirty="0">
+            <a:off x="457200" y="4023360"/>
+            <a:ext cx="8229600" cy="457200"/>
+          </a:xfrm>
+          <a:prstGeom prst="rect">
+            <a:avLst/>
+          </a:prstGeom>
+          <a:noFill/>
+          <a:ln/>
+        </p:spPr>
+        <p:txBody>
+          <a:bodyPr wrap="square" lIns="0" tIns="0" rIns="0" bIns="0" rtlCol="0" anchor="ctr"/>
+          <a:lstStyle/>
+          <a:p>
+            <a:pPr indent="0" marL="0">
+              <a:buNone/>
+            </a:pPr>
+            <a:r>
+              <a:rPr lang="en-US" sz="1500" i="1" dirty="0">
                 <a:solidFill>
                   <a:srgbClr val="1B2440"/>
                 </a:solidFill>
@@ -3010,622 +3383,7 @@
                 <a:ea typeface="Calibri" pitchFamily="34" charset="-122"/>
                 <a:cs typeface="Calibri" pitchFamily="34" charset="-120"/>
               </a:rPr>
-              <a:t>3</a:t>
-            </a:r>
-            <a:endParaRPr lang="en-US" sz="1600" dirty="0"/>
-          </a:p>
-        </p:txBody>
-      </p:sp>
-      <p:sp>
-        <p:nvSpPr>
-          <p:cNvPr id="16" name="Text 14"/>
-          <p:cNvSpPr/>
-          <p:nvPr/>
-        </p:nvSpPr>
-        <p:spPr>
-          <a:xfrm>
-            <a:off x="3328416" y="2103120"/>
-            <a:ext cx="1115568" cy="365760"/>
-          </a:xfrm>
-          <a:prstGeom prst="rect">
-            <a:avLst/>
-          </a:prstGeom>
-          <a:noFill/>
-          <a:ln/>
-        </p:spPr>
-        <p:txBody>
-          <a:bodyPr wrap="square" lIns="0" tIns="0" rIns="0" bIns="0" rtlCol="0" anchor="ctr"/>
-          <a:lstStyle/>
-          <a:p>
-            <a:pPr algn="ctr" indent="0" marL="0">
-              <a:buNone/>
-            </a:pPr>
-            <a:r>
-              <a:rPr lang="en-US" sz="1150" b="1" dirty="0">
-                <a:solidFill>
-                  <a:srgbClr val="1B2440"/>
-                </a:solidFill>
-                <a:latin typeface="Calibri" pitchFamily="34" charset="0"/>
-                <a:ea typeface="Calibri" pitchFamily="34" charset="-122"/>
-                <a:cs typeface="Calibri" pitchFamily="34" charset="-120"/>
-              </a:rPr>
-              <a:t>RAG + логи</a:t>
-            </a:r>
-            <a:endParaRPr lang="en-US" sz="1150" dirty="0"/>
-          </a:p>
-        </p:txBody>
-      </p:sp>
-      <p:sp>
-        <p:nvSpPr>
-          <p:cNvPr id="17" name="Text 15"/>
-          <p:cNvSpPr/>
-          <p:nvPr/>
-        </p:nvSpPr>
-        <p:spPr>
-          <a:xfrm>
-            <a:off x="3328416" y="2468880"/>
-            <a:ext cx="1115568" cy="685800"/>
-          </a:xfrm>
-          <a:prstGeom prst="rect">
-            <a:avLst/>
-          </a:prstGeom>
-          <a:noFill/>
-          <a:ln/>
-        </p:spPr>
-        <p:txBody>
-          <a:bodyPr wrap="square" lIns="0" tIns="0" rIns="0" bIns="0" rtlCol="0" anchor="ctr"/>
-          <a:lstStyle/>
-          <a:p>
-            <a:pPr algn="ctr" indent="0" marL="0">
-              <a:buNone/>
-            </a:pPr>
-            <a:r>
-              <a:rPr lang="en-US" sz="1050" dirty="0">
-                <a:solidFill>
-                  <a:srgbClr val="6B7280"/>
-                </a:solidFill>
-                <a:latin typeface="Calibri" pitchFamily="34" charset="0"/>
-                <a:ea typeface="Calibri" pitchFamily="34" charset="-122"/>
-                <a:cs typeface="Calibri" pitchFamily="34" charset="-120"/>
-              </a:rPr>
-              <a:t>докази з бази знань і трас</a:t>
-            </a:r>
-            <a:endParaRPr lang="en-US" sz="1050" dirty="0"/>
-          </a:p>
-        </p:txBody>
-      </p:sp>
-      <p:sp>
-        <p:nvSpPr>
-          <p:cNvPr id="18" name="Shape 16"/>
-          <p:cNvSpPr/>
-          <p:nvPr/>
-        </p:nvSpPr>
-        <p:spPr>
-          <a:xfrm>
-            <a:off x="4654296" y="1417320"/>
-            <a:ext cx="1261872" cy="1828800"/>
-          </a:xfrm>
-          <a:prstGeom prst="roundRect">
-            <a:avLst>
-              <a:gd name="adj" fmla="val 8696"/>
-            </a:avLst>
-          </a:prstGeom>
-          <a:solidFill>
-            <a:srgbClr val="F4F6FA"/>
-          </a:solidFill>
-          <a:ln/>
-          <a:effectLst>
-            <a:outerShdw sx="100000" sy="100000" kx="0" ky="0" algn="bl" rotWithShape="0" blurRad="76200" dist="25400" dir="5400000">
-              <a:srgbClr val="000000">
-                <a:alpha val="12000"/>
-              </a:srgbClr>
-            </a:outerShdw>
-          </a:effectLst>
-        </p:spPr>
-      </p:sp>
-      <p:sp>
-        <p:nvSpPr>
-          <p:cNvPr id="19" name="Shape 17"/>
-          <p:cNvSpPr/>
-          <p:nvPr/>
-        </p:nvSpPr>
-        <p:spPr>
-          <a:xfrm>
-            <a:off x="5056632" y="1554480"/>
-            <a:ext cx="457200" cy="457200"/>
-          </a:xfrm>
-          <a:prstGeom prst="ellipse">
-            <a:avLst/>
-          </a:prstGeom>
-          <a:solidFill>
-            <a:srgbClr val="D7DEEA"/>
-          </a:solidFill>
-          <a:ln/>
-        </p:spPr>
-      </p:sp>
-      <p:sp>
-        <p:nvSpPr>
-          <p:cNvPr id="20" name="Text 18"/>
-          <p:cNvSpPr/>
-          <p:nvPr/>
-        </p:nvSpPr>
-        <p:spPr>
-          <a:xfrm>
-            <a:off x="5056632" y="1554480"/>
-            <a:ext cx="457200" cy="457200"/>
-          </a:xfrm>
-          <a:prstGeom prst="rect">
-            <a:avLst/>
-          </a:prstGeom>
-          <a:noFill/>
-          <a:ln/>
-        </p:spPr>
-        <p:txBody>
-          <a:bodyPr wrap="square" lIns="0" tIns="0" rIns="0" bIns="0" rtlCol="0" anchor="ctr"/>
-          <a:lstStyle/>
-          <a:p>
-            <a:pPr algn="ctr" indent="0" marL="0">
-              <a:buNone/>
-            </a:pPr>
-            <a:r>
-              <a:rPr lang="en-US" sz="1600" b="1" dirty="0">
-                <a:solidFill>
-                  <a:srgbClr val="1B2440"/>
-                </a:solidFill>
-                <a:latin typeface="Calibri" pitchFamily="34" charset="0"/>
-                <a:ea typeface="Calibri" pitchFamily="34" charset="-122"/>
-                <a:cs typeface="Calibri" pitchFamily="34" charset="-120"/>
-              </a:rPr>
-              <a:t>4</a:t>
-            </a:r>
-            <a:endParaRPr lang="en-US" sz="1600" dirty="0"/>
-          </a:p>
-        </p:txBody>
-      </p:sp>
-      <p:sp>
-        <p:nvSpPr>
-          <p:cNvPr id="21" name="Text 19"/>
-          <p:cNvSpPr/>
-          <p:nvPr/>
-        </p:nvSpPr>
-        <p:spPr>
-          <a:xfrm>
-            <a:off x="4727448" y="2103120"/>
-            <a:ext cx="1115568" cy="365760"/>
-          </a:xfrm>
-          <a:prstGeom prst="rect">
-            <a:avLst/>
-          </a:prstGeom>
-          <a:noFill/>
-          <a:ln/>
-        </p:spPr>
-        <p:txBody>
-          <a:bodyPr wrap="square" lIns="0" tIns="0" rIns="0" bIns="0" rtlCol="0" anchor="ctr"/>
-          <a:lstStyle/>
-          <a:p>
-            <a:pPr algn="ctr" indent="0" marL="0">
-              <a:buNone/>
-            </a:pPr>
-            <a:r>
-              <a:rPr lang="en-US" sz="1150" b="1" dirty="0">
-                <a:solidFill>
-                  <a:srgbClr val="1B2440"/>
-                </a:solidFill>
-                <a:latin typeface="Calibri" pitchFamily="34" charset="0"/>
-                <a:ea typeface="Calibri" pitchFamily="34" charset="-122"/>
-                <a:cs typeface="Calibri" pitchFamily="34" charset="-120"/>
-              </a:rPr>
-              <a:t>Пропозиція</a:t>
-            </a:r>
-            <a:endParaRPr lang="en-US" sz="1150" dirty="0"/>
-          </a:p>
-        </p:txBody>
-      </p:sp>
-      <p:sp>
-        <p:nvSpPr>
-          <p:cNvPr id="22" name="Text 20"/>
-          <p:cNvSpPr/>
-          <p:nvPr/>
-        </p:nvSpPr>
-        <p:spPr>
-          <a:xfrm>
-            <a:off x="4727448" y="2468880"/>
-            <a:ext cx="1115568" cy="685800"/>
-          </a:xfrm>
-          <a:prstGeom prst="rect">
-            <a:avLst/>
-          </a:prstGeom>
-          <a:noFill/>
-          <a:ln/>
-        </p:spPr>
-        <p:txBody>
-          <a:bodyPr wrap="square" lIns="0" tIns="0" rIns="0" bIns="0" rtlCol="0" anchor="ctr"/>
-          <a:lstStyle/>
-          <a:p>
-            <a:pPr algn="ctr" indent="0" marL="0">
-              <a:buNone/>
-            </a:pPr>
-            <a:r>
-              <a:rPr lang="en-US" sz="1050" dirty="0">
-                <a:solidFill>
-                  <a:srgbClr val="6B7280"/>
-                </a:solidFill>
-                <a:latin typeface="Calibri" pitchFamily="34" charset="0"/>
-                <a:ea typeface="Calibri" pitchFamily="34" charset="-122"/>
-                <a:cs typeface="Calibri" pitchFamily="34" charset="-120"/>
-              </a:rPr>
-              <a:t>дія з превʼю і сумою</a:t>
-            </a:r>
-            <a:endParaRPr lang="en-US" sz="1050" dirty="0"/>
-          </a:p>
-        </p:txBody>
-      </p:sp>
-      <p:sp>
-        <p:nvSpPr>
-          <p:cNvPr id="23" name="Shape 21"/>
-          <p:cNvSpPr/>
-          <p:nvPr/>
-        </p:nvSpPr>
-        <p:spPr>
-          <a:xfrm>
-            <a:off x="6053328" y="1417320"/>
-            <a:ext cx="1261872" cy="1828800"/>
-          </a:xfrm>
-          <a:prstGeom prst="roundRect">
-            <a:avLst>
-              <a:gd name="adj" fmla="val 8696"/>
-            </a:avLst>
-          </a:prstGeom>
-          <a:solidFill>
-            <a:srgbClr val="FFF4E0"/>
-          </a:solidFill>
-          <a:ln/>
-          <a:effectLst>
-            <a:outerShdw sx="100000" sy="100000" kx="0" ky="0" algn="bl" rotWithShape="0" blurRad="76200" dist="25400" dir="5400000">
-              <a:srgbClr val="000000">
-                <a:alpha val="12000"/>
-              </a:srgbClr>
-            </a:outerShdw>
-          </a:effectLst>
-        </p:spPr>
-      </p:sp>
-      <p:sp>
-        <p:nvSpPr>
-          <p:cNvPr id="24" name="Shape 22"/>
-          <p:cNvSpPr/>
-          <p:nvPr/>
-        </p:nvSpPr>
-        <p:spPr>
-          <a:xfrm>
-            <a:off x="6455664" y="1554480"/>
-            <a:ext cx="457200" cy="457200"/>
-          </a:xfrm>
-          <a:prstGeom prst="ellipse">
-            <a:avLst/>
-          </a:prstGeom>
-          <a:solidFill>
-            <a:srgbClr val="F2A541"/>
-          </a:solidFill>
-          <a:ln/>
-        </p:spPr>
-      </p:sp>
-      <p:sp>
-        <p:nvSpPr>
-          <p:cNvPr id="25" name="Text 23"/>
-          <p:cNvSpPr/>
-          <p:nvPr/>
-        </p:nvSpPr>
-        <p:spPr>
-          <a:xfrm>
-            <a:off x="6455664" y="1554480"/>
-            <a:ext cx="457200" cy="457200"/>
-          </a:xfrm>
-          <a:prstGeom prst="rect">
-            <a:avLst/>
-          </a:prstGeom>
-          <a:noFill/>
-          <a:ln/>
-        </p:spPr>
-        <p:txBody>
-          <a:bodyPr wrap="square" lIns="0" tIns="0" rIns="0" bIns="0" rtlCol="0" anchor="ctr"/>
-          <a:lstStyle/>
-          <a:p>
-            <a:pPr algn="ctr" indent="0" marL="0">
-              <a:buNone/>
-            </a:pPr>
-            <a:r>
-              <a:rPr lang="en-US" sz="1600" b="1" dirty="0">
-                <a:solidFill>
-                  <a:srgbClr val="1B2440"/>
-                </a:solidFill>
-                <a:latin typeface="Calibri" pitchFamily="34" charset="0"/>
-                <a:ea typeface="Calibri" pitchFamily="34" charset="-122"/>
-                <a:cs typeface="Calibri" pitchFamily="34" charset="-120"/>
-              </a:rPr>
-              <a:t>5</a:t>
-            </a:r>
-            <a:endParaRPr lang="en-US" sz="1600" dirty="0"/>
-          </a:p>
-        </p:txBody>
-      </p:sp>
-      <p:sp>
-        <p:nvSpPr>
-          <p:cNvPr id="26" name="Text 24"/>
-          <p:cNvSpPr/>
-          <p:nvPr/>
-        </p:nvSpPr>
-        <p:spPr>
-          <a:xfrm>
-            <a:off x="6126480" y="2103120"/>
-            <a:ext cx="1115568" cy="365760"/>
-          </a:xfrm>
-          <a:prstGeom prst="rect">
-            <a:avLst/>
-          </a:prstGeom>
-          <a:noFill/>
-          <a:ln/>
-        </p:spPr>
-        <p:txBody>
-          <a:bodyPr wrap="square" lIns="0" tIns="0" rIns="0" bIns="0" rtlCol="0" anchor="ctr"/>
-          <a:lstStyle/>
-          <a:p>
-            <a:pPr algn="ctr" indent="0" marL="0">
-              <a:buNone/>
-            </a:pPr>
-            <a:r>
-              <a:rPr lang="en-US" sz="1150" b="1" dirty="0">
-                <a:solidFill>
-                  <a:srgbClr val="1B2440"/>
-                </a:solidFill>
-                <a:latin typeface="Calibri" pitchFamily="34" charset="0"/>
-                <a:ea typeface="Calibri" pitchFamily="34" charset="-122"/>
-                <a:cs typeface="Calibri" pitchFamily="34" charset="-120"/>
-              </a:rPr>
-              <a:t>Підтвердження</a:t>
-            </a:r>
-            <a:endParaRPr lang="en-US" sz="1150" dirty="0"/>
-          </a:p>
-        </p:txBody>
-      </p:sp>
-      <p:sp>
-        <p:nvSpPr>
-          <p:cNvPr id="27" name="Text 25"/>
-          <p:cNvSpPr/>
-          <p:nvPr/>
-        </p:nvSpPr>
-        <p:spPr>
-          <a:xfrm>
-            <a:off x="6126480" y="2468880"/>
-            <a:ext cx="1115568" cy="685800"/>
-          </a:xfrm>
-          <a:prstGeom prst="rect">
-            <a:avLst/>
-          </a:prstGeom>
-          <a:noFill/>
-          <a:ln/>
-        </p:spPr>
-        <p:txBody>
-          <a:bodyPr wrap="square" lIns="0" tIns="0" rIns="0" bIns="0" rtlCol="0" anchor="ctr"/>
-          <a:lstStyle/>
-          <a:p>
-            <a:pPr algn="ctr" indent="0" marL="0">
-              <a:buNone/>
-            </a:pPr>
-            <a:r>
-              <a:rPr lang="en-US" sz="1050" dirty="0">
-                <a:solidFill>
-                  <a:srgbClr val="6B7280"/>
-                </a:solidFill>
-                <a:latin typeface="Calibri" pitchFamily="34" charset="0"/>
-                <a:ea typeface="Calibri" pitchFamily="34" charset="-122"/>
-                <a:cs typeface="Calibri" pitchFamily="34" charset="-120"/>
-              </a:rPr>
-              <a:t>лише власник, одним кліком</a:t>
-            </a:r>
-            <a:endParaRPr lang="en-US" sz="1050" dirty="0"/>
-          </a:p>
-        </p:txBody>
-      </p:sp>
-      <p:sp>
-        <p:nvSpPr>
-          <p:cNvPr id="28" name="Shape 26"/>
-          <p:cNvSpPr/>
-          <p:nvPr/>
-        </p:nvSpPr>
-        <p:spPr>
-          <a:xfrm>
-            <a:off x="7452360" y="1417320"/>
-            <a:ext cx="1261872" cy="1828800"/>
-          </a:xfrm>
-          <a:prstGeom prst="roundRect">
-            <a:avLst>
-              <a:gd name="adj" fmla="val 8696"/>
-            </a:avLst>
-          </a:prstGeom>
-          <a:solidFill>
-            <a:srgbClr val="F4F6FA"/>
-          </a:solidFill>
-          <a:ln/>
-          <a:effectLst>
-            <a:outerShdw sx="100000" sy="100000" kx="0" ky="0" algn="bl" rotWithShape="0" blurRad="76200" dist="25400" dir="5400000">
-              <a:srgbClr val="000000">
-                <a:alpha val="12000"/>
-              </a:srgbClr>
-            </a:outerShdw>
-          </a:effectLst>
-        </p:spPr>
-      </p:sp>
-      <p:sp>
-        <p:nvSpPr>
-          <p:cNvPr id="29" name="Shape 27"/>
-          <p:cNvSpPr/>
-          <p:nvPr/>
-        </p:nvSpPr>
-        <p:spPr>
-          <a:xfrm>
-            <a:off x="7854696" y="1554480"/>
-            <a:ext cx="457200" cy="457200"/>
-          </a:xfrm>
-          <a:prstGeom prst="ellipse">
-            <a:avLst/>
-          </a:prstGeom>
-          <a:solidFill>
-            <a:srgbClr val="D7DEEA"/>
-          </a:solidFill>
-          <a:ln/>
-        </p:spPr>
-      </p:sp>
-      <p:sp>
-        <p:nvSpPr>
-          <p:cNvPr id="30" name="Text 28"/>
-          <p:cNvSpPr/>
-          <p:nvPr/>
-        </p:nvSpPr>
-        <p:spPr>
-          <a:xfrm>
-            <a:off x="7854696" y="1554480"/>
-            <a:ext cx="457200" cy="457200"/>
-          </a:xfrm>
-          <a:prstGeom prst="rect">
-            <a:avLst/>
-          </a:prstGeom>
-          <a:noFill/>
-          <a:ln/>
-        </p:spPr>
-        <p:txBody>
-          <a:bodyPr wrap="square" lIns="0" tIns="0" rIns="0" bIns="0" rtlCol="0" anchor="ctr"/>
-          <a:lstStyle/>
-          <a:p>
-            <a:pPr algn="ctr" indent="0" marL="0">
-              <a:buNone/>
-            </a:pPr>
-            <a:r>
-              <a:rPr lang="en-US" sz="1600" b="1" dirty="0">
-                <a:solidFill>
-                  <a:srgbClr val="1B2440"/>
-                </a:solidFill>
-                <a:latin typeface="Calibri" pitchFamily="34" charset="0"/>
-                <a:ea typeface="Calibri" pitchFamily="34" charset="-122"/>
-                <a:cs typeface="Calibri" pitchFamily="34" charset="-120"/>
-              </a:rPr>
-              <a:t>6</a:t>
-            </a:r>
-            <a:endParaRPr lang="en-US" sz="1600" dirty="0"/>
-          </a:p>
-        </p:txBody>
-      </p:sp>
-      <p:sp>
-        <p:nvSpPr>
-          <p:cNvPr id="31" name="Text 29"/>
-          <p:cNvSpPr/>
-          <p:nvPr/>
-        </p:nvSpPr>
-        <p:spPr>
-          <a:xfrm>
-            <a:off x="7525512" y="2103120"/>
-            <a:ext cx="1115568" cy="365760"/>
-          </a:xfrm>
-          <a:prstGeom prst="rect">
-            <a:avLst/>
-          </a:prstGeom>
-          <a:noFill/>
-          <a:ln/>
-        </p:spPr>
-        <p:txBody>
-          <a:bodyPr wrap="square" lIns="0" tIns="0" rIns="0" bIns="0" rtlCol="0" anchor="ctr"/>
-          <a:lstStyle/>
-          <a:p>
-            <a:pPr algn="ctr" indent="0" marL="0">
-              <a:buNone/>
-            </a:pPr>
-            <a:r>
-              <a:rPr lang="en-US" sz="1150" b="1" dirty="0">
-                <a:solidFill>
-                  <a:srgbClr val="1B2440"/>
-                </a:solidFill>
-                <a:latin typeface="Calibri" pitchFamily="34" charset="0"/>
-                <a:ea typeface="Calibri" pitchFamily="34" charset="-122"/>
-                <a:cs typeface="Calibri" pitchFamily="34" charset="-120"/>
-              </a:rPr>
-              <a:t>Виконання</a:t>
-            </a:r>
-            <a:endParaRPr lang="en-US" sz="1150" dirty="0"/>
-          </a:p>
-        </p:txBody>
-      </p:sp>
-      <p:sp>
-        <p:nvSpPr>
-          <p:cNvPr id="32" name="Text 30"/>
-          <p:cNvSpPr/>
-          <p:nvPr/>
-        </p:nvSpPr>
-        <p:spPr>
-          <a:xfrm>
-            <a:off x="7525512" y="2468880"/>
-            <a:ext cx="1115568" cy="685800"/>
-          </a:xfrm>
-          <a:prstGeom prst="rect">
-            <a:avLst/>
-          </a:prstGeom>
-          <a:noFill/>
-          <a:ln/>
-        </p:spPr>
-        <p:txBody>
-          <a:bodyPr wrap="square" lIns="0" tIns="0" rIns="0" bIns="0" rtlCol="0" anchor="ctr"/>
-          <a:lstStyle/>
-          <a:p>
-            <a:pPr algn="ctr" indent="0" marL="0">
-              <a:buNone/>
-            </a:pPr>
-            <a:r>
-              <a:rPr lang="en-US" sz="1050" dirty="0">
-                <a:solidFill>
-                  <a:srgbClr val="6B7280"/>
-                </a:solidFill>
-                <a:latin typeface="Calibri" pitchFamily="34" charset="0"/>
-                <a:ea typeface="Calibri" pitchFamily="34" charset="-122"/>
-                <a:cs typeface="Calibri" pitchFamily="34" charset="-120"/>
-              </a:rPr>
-              <a:t>атомарно, з перевіркою і аудитом</a:t>
-            </a:r>
-            <a:endParaRPr lang="en-US" sz="1050" dirty="0"/>
-          </a:p>
-        </p:txBody>
-      </p:sp>
-      <p:sp>
-        <p:nvSpPr>
-          <p:cNvPr id="33" name="Text 31"/>
-          <p:cNvSpPr/>
-          <p:nvPr/>
-        </p:nvSpPr>
-        <p:spPr>
-          <a:xfrm>
-            <a:off x="457200" y="3657600"/>
-            <a:ext cx="8229600" cy="548640"/>
-          </a:xfrm>
-          <a:prstGeom prst="rect">
-            <a:avLst/>
-          </a:prstGeom>
-          <a:noFill/>
-          <a:ln/>
-        </p:spPr>
-        <p:txBody>
-          <a:bodyPr wrap="square" lIns="0" tIns="0" rIns="0" bIns="0" rtlCol="0" anchor="ctr"/>
-          <a:lstStyle/>
-          <a:p>
-            <a:pPr indent="0" marL="0">
-              <a:buNone/>
-            </a:pPr>
-            <a:r>
-              <a:rPr lang="en-US" sz="1500" i="1" dirty="0">
-                <a:solidFill>
-                  <a:srgbClr val="1B2440"/>
-                </a:solidFill>
-                <a:latin typeface="Calibri" pitchFamily="34" charset="0"/>
-                <a:ea typeface="Calibri" pitchFamily="34" charset="-122"/>
-                <a:cs typeface="Calibri" pitchFamily="34" charset="-120"/>
-              </a:rPr>
-              <a:t>Модель лише читає і пропонує. Гроші, права і ізоляція клієнтів контролюються кодом, а не промптом.</a:t>
+              <a:t>Ми не будуємо SaaS і не замінюємо саппорт: ми прибираємо з його черги рутину.</a:t>
             </a:r>
             <a:endParaRPr lang="en-US" sz="1500" dirty="0"/>
           </a:p>
@@ -3645,7 +3403,7 @@
     <p:bg>
       <p:bgPr>
         <a:solidFill>
-          <a:srgbClr val="F4F6FA"/>
+          <a:srgbClr val="FFFFFF"/>
         </a:solidFill>
       </p:bgPr>
     </p:bg>
@@ -3696,7 +3454,7 @@
                 <a:ea typeface="Cambria" pitchFamily="34" charset="-122"/>
                 <a:cs typeface="Cambria" pitchFamily="34" charset="-120"/>
               </a:rPr>
-              <a:t>Живе демо: три типові звернення</a:t>
+              <a:t>Як це працює</a:t>
             </a:r>
             <a:endParaRPr lang="en-US" sz="3000" dirty="0"/>
           </a:p>
@@ -3710,16 +3468,16 @@
         </p:nvSpPr>
         <p:spPr>
           <a:xfrm>
-            <a:off x="457200" y="1280160"/>
-            <a:ext cx="2606040" cy="3017520"/>
+            <a:off x="457200" y="1417320"/>
+            <a:ext cx="1261872" cy="1828800"/>
           </a:xfrm>
           <a:prstGeom prst="roundRect">
             <a:avLst>
-              <a:gd name="adj" fmla="val 4211"/>
+              <a:gd name="adj" fmla="val 8696"/>
             </a:avLst>
           </a:prstGeom>
           <a:solidFill>
-            <a:srgbClr val="FFFFFF"/>
+            <a:srgbClr val="F4F6FA"/>
           </a:solidFill>
           <a:ln/>
           <a:effectLst>
@@ -3739,14 +3497,14 @@
         </p:nvSpPr>
         <p:spPr>
           <a:xfrm>
-            <a:off x="685800" y="1463040"/>
-            <a:ext cx="411480" cy="411480"/>
+            <a:off x="859536" y="1554480"/>
+            <a:ext cx="457200" cy="457200"/>
           </a:xfrm>
           <a:prstGeom prst="ellipse">
             <a:avLst/>
           </a:prstGeom>
           <a:solidFill>
-            <a:srgbClr val="2A9D8F"/>
+            <a:srgbClr val="D7DEEA"/>
           </a:solidFill>
           <a:ln/>
         </p:spPr>
@@ -3759,24 +3517,24 @@
         </p:nvSpPr>
         <p:spPr>
           <a:xfrm>
-            <a:off x="685800" y="2011680"/>
-            <a:ext cx="2194560" cy="685800"/>
-          </a:xfrm>
-          <a:prstGeom prst="rect">
-            <a:avLst/>
-          </a:prstGeom>
-          <a:noFill/>
-          <a:ln/>
-        </p:spPr>
-        <p:txBody>
-          <a:bodyPr wrap="square" lIns="0" tIns="0" rIns="0" bIns="0" rtlCol="0" anchor="t"/>
-          <a:lstStyle/>
-          <a:p>
-            <a:pPr indent="0" marL="0">
-              <a:buNone/>
-            </a:pPr>
-            <a:r>
-              <a:rPr lang="en-US" sz="1500" b="1" dirty="0">
+            <a:off x="859536" y="1554480"/>
+            <a:ext cx="457200" cy="457200"/>
+          </a:xfrm>
+          <a:prstGeom prst="rect">
+            <a:avLst/>
+          </a:prstGeom>
+          <a:noFill/>
+          <a:ln/>
+        </p:spPr>
+        <p:txBody>
+          <a:bodyPr wrap="square" lIns="0" tIns="0" rIns="0" bIns="0" rtlCol="0" anchor="ctr"/>
+          <a:lstStyle/>
+          <a:p>
+            <a:pPr algn="ctr" indent="0" marL="0">
+              <a:buNone/>
+            </a:pPr>
+            <a:r>
+              <a:rPr lang="en-US" sz="1600" b="1" dirty="0">
                 <a:solidFill>
                   <a:srgbClr val="1B2440"/>
                 </a:solidFill>
@@ -3784,9 +3542,9 @@
                 <a:ea typeface="Calibri" pitchFamily="34" charset="-122"/>
                 <a:cs typeface="Calibri" pitchFamily="34" charset="-120"/>
               </a:rPr>
-              <a:t>Промокод не працює на касі</a:t>
-            </a:r>
-            <a:endParaRPr lang="en-US" sz="1500" dirty="0"/>
+              <a:t>1</a:t>
+            </a:r>
+            <a:endParaRPr lang="en-US" sz="1600" dirty="0"/>
           </a:p>
         </p:txBody>
       </p:sp>
@@ -3798,24 +3556,63 @@
         </p:nvSpPr>
         <p:spPr>
           <a:xfrm>
-            <a:off x="685800" y="2743200"/>
-            <a:ext cx="2194560" cy="1463040"/>
-          </a:xfrm>
-          <a:prstGeom prst="rect">
-            <a:avLst/>
-          </a:prstGeom>
-          <a:noFill/>
-          <a:ln/>
-        </p:spPr>
-        <p:txBody>
-          <a:bodyPr wrap="square" lIns="0" tIns="0" rIns="0" bIns="0" rtlCol="0" anchor="t"/>
-          <a:lstStyle/>
-          <a:p>
-            <a:pPr indent="0" marL="0">
-              <a:buNone/>
-            </a:pPr>
-            <a:r>
-              <a:rPr lang="en-US" sz="1150" dirty="0">
+            <a:off x="530352" y="2103120"/>
+            <a:ext cx="1115568" cy="365760"/>
+          </a:xfrm>
+          <a:prstGeom prst="rect">
+            <a:avLst/>
+          </a:prstGeom>
+          <a:noFill/>
+          <a:ln/>
+        </p:spPr>
+        <p:txBody>
+          <a:bodyPr wrap="square" lIns="0" tIns="0" rIns="0" bIns="0" rtlCol="0" anchor="ctr"/>
+          <a:lstStyle/>
+          <a:p>
+            <a:pPr algn="ctr" indent="0" marL="0">
+              <a:buNone/>
+            </a:pPr>
+            <a:r>
+              <a:rPr lang="en-US" sz="1150" b="1" dirty="0">
+                <a:solidFill>
+                  <a:srgbClr val="1B2440"/>
+                </a:solidFill>
+                <a:latin typeface="Calibri" pitchFamily="34" charset="0"/>
+                <a:ea typeface="Calibri" pitchFamily="34" charset="-122"/>
+                <a:cs typeface="Calibri" pitchFamily="34" charset="-120"/>
+              </a:rPr>
+              <a:t>Звернення</a:t>
+            </a:r>
+            <a:endParaRPr lang="en-US" sz="1150" dirty="0"/>
+          </a:p>
+        </p:txBody>
+      </p:sp>
+      <p:sp>
+        <p:nvSpPr>
+          <p:cNvPr id="7" name="Text 5"/>
+          <p:cNvSpPr/>
+          <p:nvPr/>
+        </p:nvSpPr>
+        <p:spPr>
+          <a:xfrm>
+            <a:off x="530352" y="2468880"/>
+            <a:ext cx="1115568" cy="685800"/>
+          </a:xfrm>
+          <a:prstGeom prst="rect">
+            <a:avLst/>
+          </a:prstGeom>
+          <a:noFill/>
+          <a:ln/>
+        </p:spPr>
+        <p:txBody>
+          <a:bodyPr wrap="square" lIns="0" tIns="0" rIns="0" bIns="0" rtlCol="0" anchor="ctr"/>
+          <a:lstStyle/>
+          <a:p>
+            <a:pPr algn="ctr" indent="0" marL="0">
+              <a:buNone/>
+            </a:pPr>
+            <a:r>
+              <a:rPr lang="en-US" sz="1050" dirty="0">
                 <a:solidFill>
                   <a:srgbClr val="6B7280"/>
                 </a:solidFill>
@@ -3823,30 +3620,30 @@
                 <a:ea typeface="Calibri" pitchFamily="34" charset="-122"/>
                 <a:cs typeface="Calibri" pitchFamily="34" charset="-120"/>
               </a:rPr>
-              <a:t>Gemma знаходить POS_SYNC_FAILED у трасі, бачить версію 6 замість 7, пропонує resync_pos. Після підтвердження чек проходить.</a:t>
-            </a:r>
-            <a:endParaRPr lang="en-US" sz="1150" dirty="0"/>
-          </a:p>
-        </p:txBody>
-      </p:sp>
-      <p:sp>
-        <p:nvSpPr>
-          <p:cNvPr id="7" name="Shape 5"/>
-          <p:cNvSpPr/>
-          <p:nvPr/>
-        </p:nvSpPr>
-        <p:spPr>
-          <a:xfrm>
-            <a:off x="3246120" y="1280160"/>
-            <a:ext cx="2606040" cy="3017520"/>
+              <a:t>власник пише як звик</a:t>
+            </a:r>
+            <a:endParaRPr lang="en-US" sz="1050" dirty="0"/>
+          </a:p>
+        </p:txBody>
+      </p:sp>
+      <p:sp>
+        <p:nvSpPr>
+          <p:cNvPr id="8" name="Shape 6"/>
+          <p:cNvSpPr/>
+          <p:nvPr/>
+        </p:nvSpPr>
+        <p:spPr>
+          <a:xfrm>
+            <a:off x="1856232" y="1417320"/>
+            <a:ext cx="1261872" cy="1828800"/>
           </a:xfrm>
           <a:prstGeom prst="roundRect">
             <a:avLst>
-              <a:gd name="adj" fmla="val 4211"/>
+              <a:gd name="adj" fmla="val 8696"/>
             </a:avLst>
           </a:prstGeom>
           <a:solidFill>
-            <a:srgbClr val="FFFFFF"/>
+            <a:srgbClr val="F4F6FA"/>
           </a:solidFill>
           <a:ln/>
           <a:effectLst>
@@ -3860,50 +3657,50 @@
       </p:sp>
       <p:sp>
         <p:nvSpPr>
-          <p:cNvPr id="8" name="Shape 6"/>
-          <p:cNvSpPr/>
-          <p:nvPr/>
-        </p:nvSpPr>
-        <p:spPr>
-          <a:xfrm>
-            <a:off x="3474720" y="1463040"/>
-            <a:ext cx="411480" cy="411480"/>
+          <p:cNvPr id="9" name="Shape 7"/>
+          <p:cNvSpPr/>
+          <p:nvPr/>
+        </p:nvSpPr>
+        <p:spPr>
+          <a:xfrm>
+            <a:off x="2258568" y="1554480"/>
+            <a:ext cx="457200" cy="457200"/>
           </a:xfrm>
           <a:prstGeom prst="ellipse">
             <a:avLst/>
           </a:prstGeom>
           <a:solidFill>
-            <a:srgbClr val="C8553D"/>
+            <a:srgbClr val="D7DEEA"/>
           </a:solidFill>
           <a:ln/>
         </p:spPr>
       </p:sp>
       <p:sp>
         <p:nvSpPr>
-          <p:cNvPr id="9" name="Text 7"/>
-          <p:cNvSpPr/>
-          <p:nvPr/>
-        </p:nvSpPr>
-        <p:spPr>
-          <a:xfrm>
-            <a:off x="3474720" y="2011680"/>
-            <a:ext cx="2194560" cy="685800"/>
-          </a:xfrm>
-          <a:prstGeom prst="rect">
-            <a:avLst/>
-          </a:prstGeom>
-          <a:noFill/>
-          <a:ln/>
-        </p:spPr>
-        <p:txBody>
-          <a:bodyPr wrap="square" lIns="0" tIns="0" rIns="0" bIns="0" rtlCol="0" anchor="t"/>
-          <a:lstStyle/>
-          <a:p>
-            <a:pPr indent="0" marL="0">
-              <a:buNone/>
-            </a:pPr>
-            <a:r>
-              <a:rPr lang="en-US" sz="1500" b="1" dirty="0">
+          <p:cNvPr id="10" name="Text 8"/>
+          <p:cNvSpPr/>
+          <p:nvPr/>
+        </p:nvSpPr>
+        <p:spPr>
+          <a:xfrm>
+            <a:off x="2258568" y="1554480"/>
+            <a:ext cx="457200" cy="457200"/>
+          </a:xfrm>
+          <a:prstGeom prst="rect">
+            <a:avLst/>
+          </a:prstGeom>
+          <a:noFill/>
+          <a:ln/>
+        </p:spPr>
+        <p:txBody>
+          <a:bodyPr wrap="square" lIns="0" tIns="0" rIns="0" bIns="0" rtlCol="0" anchor="ctr"/>
+          <a:lstStyle/>
+          <a:p>
+            <a:pPr algn="ctr" indent="0" marL="0">
+              <a:buNone/>
+            </a:pPr>
+            <a:r>
+              <a:rPr lang="en-US" sz="1600" b="1" dirty="0">
                 <a:solidFill>
                   <a:srgbClr val="1B2440"/>
                 </a:solidFill>
@@ -3911,38 +3708,77 @@
                 <a:ea typeface="Calibri" pitchFamily="34" charset="-122"/>
                 <a:cs typeface="Calibri" pitchFamily="34" charset="-120"/>
               </a:rPr>
-              <a:t>З мене списали двічі</a:t>
-            </a:r>
-            <a:endParaRPr lang="en-US" sz="1500" dirty="0"/>
-          </a:p>
-        </p:txBody>
-      </p:sp>
-      <p:sp>
-        <p:nvSpPr>
-          <p:cNvPr id="10" name="Text 8"/>
-          <p:cNvSpPr/>
-          <p:nvPr/>
-        </p:nvSpPr>
-        <p:spPr>
-          <a:xfrm>
-            <a:off x="3474720" y="2743200"/>
-            <a:ext cx="2194560" cy="1463040"/>
-          </a:xfrm>
-          <a:prstGeom prst="rect">
-            <a:avLst/>
-          </a:prstGeom>
-          <a:noFill/>
-          <a:ln/>
-        </p:spPr>
-        <p:txBody>
-          <a:bodyPr wrap="square" lIns="0" tIns="0" rIns="0" bIns="0" rtlCol="0" anchor="t"/>
-          <a:lstStyle/>
-          <a:p>
-            <a:pPr indent="0" marL="0">
-              <a:buNone/>
-            </a:pPr>
-            <a:r>
-              <a:rPr lang="en-US" sz="1150" dirty="0">
+              <a:t>2</a:t>
+            </a:r>
+            <a:endParaRPr lang="en-US" sz="1600" dirty="0"/>
+          </a:p>
+        </p:txBody>
+      </p:sp>
+      <p:sp>
+        <p:nvSpPr>
+          <p:cNvPr id="11" name="Text 9"/>
+          <p:cNvSpPr/>
+          <p:nvPr/>
+        </p:nvSpPr>
+        <p:spPr>
+          <a:xfrm>
+            <a:off x="1929384" y="2103120"/>
+            <a:ext cx="1115568" cy="365760"/>
+          </a:xfrm>
+          <a:prstGeom prst="rect">
+            <a:avLst/>
+          </a:prstGeom>
+          <a:noFill/>
+          <a:ln/>
+        </p:spPr>
+        <p:txBody>
+          <a:bodyPr wrap="square" lIns="0" tIns="0" rIns="0" bIns="0" rtlCol="0" anchor="ctr"/>
+          <a:lstStyle/>
+          <a:p>
+            <a:pPr algn="ctr" indent="0" marL="0">
+              <a:buNone/>
+            </a:pPr>
+            <a:r>
+              <a:rPr lang="en-US" sz="1150" b="1" dirty="0">
+                <a:solidFill>
+                  <a:srgbClr val="1B2440"/>
+                </a:solidFill>
+                <a:latin typeface="Calibri" pitchFamily="34" charset="0"/>
+                <a:ea typeface="Calibri" pitchFamily="34" charset="-122"/>
+                <a:cs typeface="Calibri" pitchFamily="34" charset="-120"/>
+              </a:rPr>
+              <a:t>Gemma</a:t>
+            </a:r>
+            <a:endParaRPr lang="en-US" sz="1150" dirty="0"/>
+          </a:p>
+        </p:txBody>
+      </p:sp>
+      <p:sp>
+        <p:nvSpPr>
+          <p:cNvPr id="12" name="Text 10"/>
+          <p:cNvSpPr/>
+          <p:nvPr/>
+        </p:nvSpPr>
+        <p:spPr>
+          <a:xfrm>
+            <a:off x="1929384" y="2468880"/>
+            <a:ext cx="1115568" cy="685800"/>
+          </a:xfrm>
+          <a:prstGeom prst="rect">
+            <a:avLst/>
+          </a:prstGeom>
+          <a:noFill/>
+          <a:ln/>
+        </p:spPr>
+        <p:txBody>
+          <a:bodyPr wrap="square" lIns="0" tIns="0" rIns="0" bIns="0" rtlCol="0" anchor="ctr"/>
+          <a:lstStyle/>
+          <a:p>
+            <a:pPr algn="ctr" indent="0" marL="0">
+              <a:buNone/>
+            </a:pPr>
+            <a:r>
+              <a:rPr lang="en-US" sz="1050" dirty="0">
                 <a:solidFill>
                   <a:srgbClr val="6B7280"/>
                 </a:solidFill>
@@ -3950,30 +3786,30 @@
                 <a:ea typeface="Calibri" pitchFamily="34" charset="-122"/>
                 <a:cs typeface="Calibri" pitchFamily="34" charset="-120"/>
               </a:rPr>
-              <a:t>Знаходить дубль підписки після SUBSCRIPTION_CREATE_RETRY. Окремо: скасувати дубль і подати запит на повернення (pending_review, гроші не рухаються без людини).</a:t>
-            </a:r>
-            <a:endParaRPr lang="en-US" sz="1150" dirty="0"/>
-          </a:p>
-        </p:txBody>
-      </p:sp>
-      <p:sp>
-        <p:nvSpPr>
-          <p:cNvPr id="11" name="Shape 9"/>
-          <p:cNvSpPr/>
-          <p:nvPr/>
-        </p:nvSpPr>
-        <p:spPr>
-          <a:xfrm>
-            <a:off x="6035040" y="1280160"/>
-            <a:ext cx="2606040" cy="3017520"/>
+              <a:t>інтент і тон клієнта, вибір інструментів</a:t>
+            </a:r>
+            <a:endParaRPr lang="en-US" sz="1050" dirty="0"/>
+          </a:p>
+        </p:txBody>
+      </p:sp>
+      <p:sp>
+        <p:nvSpPr>
+          <p:cNvPr id="13" name="Shape 11"/>
+          <p:cNvSpPr/>
+          <p:nvPr/>
+        </p:nvSpPr>
+        <p:spPr>
+          <a:xfrm>
+            <a:off x="3255264" y="1417320"/>
+            <a:ext cx="1261872" cy="1828800"/>
           </a:xfrm>
           <a:prstGeom prst="roundRect">
             <a:avLst>
-              <a:gd name="adj" fmla="val 4211"/>
+              <a:gd name="adj" fmla="val 8696"/>
             </a:avLst>
           </a:prstGeom>
           <a:solidFill>
-            <a:srgbClr val="FFFFFF"/>
+            <a:srgbClr val="F4F6FA"/>
           </a:solidFill>
           <a:ln/>
           <a:effectLst>
@@ -3987,14 +3823,346 @@
       </p:sp>
       <p:sp>
         <p:nvSpPr>
-          <p:cNvPr id="12" name="Shape 10"/>
-          <p:cNvSpPr/>
-          <p:nvPr/>
-        </p:nvSpPr>
-        <p:spPr>
-          <a:xfrm>
-            <a:off x="6263640" y="1463040"/>
-            <a:ext cx="411480" cy="411480"/>
+          <p:cNvPr id="14" name="Shape 12"/>
+          <p:cNvSpPr/>
+          <p:nvPr/>
+        </p:nvSpPr>
+        <p:spPr>
+          <a:xfrm>
+            <a:off x="3657600" y="1554480"/>
+            <a:ext cx="457200" cy="457200"/>
+          </a:xfrm>
+          <a:prstGeom prst="ellipse">
+            <a:avLst/>
+          </a:prstGeom>
+          <a:solidFill>
+            <a:srgbClr val="D7DEEA"/>
+          </a:solidFill>
+          <a:ln/>
+        </p:spPr>
+      </p:sp>
+      <p:sp>
+        <p:nvSpPr>
+          <p:cNvPr id="15" name="Text 13"/>
+          <p:cNvSpPr/>
+          <p:nvPr/>
+        </p:nvSpPr>
+        <p:spPr>
+          <a:xfrm>
+            <a:off x="3657600" y="1554480"/>
+            <a:ext cx="457200" cy="457200"/>
+          </a:xfrm>
+          <a:prstGeom prst="rect">
+            <a:avLst/>
+          </a:prstGeom>
+          <a:noFill/>
+          <a:ln/>
+        </p:spPr>
+        <p:txBody>
+          <a:bodyPr wrap="square" lIns="0" tIns="0" rIns="0" bIns="0" rtlCol="0" anchor="ctr"/>
+          <a:lstStyle/>
+          <a:p>
+            <a:pPr algn="ctr" indent="0" marL="0">
+              <a:buNone/>
+            </a:pPr>
+            <a:r>
+              <a:rPr lang="en-US" sz="1600" b="1" dirty="0">
+                <a:solidFill>
+                  <a:srgbClr val="1B2440"/>
+                </a:solidFill>
+                <a:latin typeface="Calibri" pitchFamily="34" charset="0"/>
+                <a:ea typeface="Calibri" pitchFamily="34" charset="-122"/>
+                <a:cs typeface="Calibri" pitchFamily="34" charset="-120"/>
+              </a:rPr>
+              <a:t>3</a:t>
+            </a:r>
+            <a:endParaRPr lang="en-US" sz="1600" dirty="0"/>
+          </a:p>
+        </p:txBody>
+      </p:sp>
+      <p:sp>
+        <p:nvSpPr>
+          <p:cNvPr id="16" name="Text 14"/>
+          <p:cNvSpPr/>
+          <p:nvPr/>
+        </p:nvSpPr>
+        <p:spPr>
+          <a:xfrm>
+            <a:off x="3328416" y="2103120"/>
+            <a:ext cx="1115568" cy="365760"/>
+          </a:xfrm>
+          <a:prstGeom prst="rect">
+            <a:avLst/>
+          </a:prstGeom>
+          <a:noFill/>
+          <a:ln/>
+        </p:spPr>
+        <p:txBody>
+          <a:bodyPr wrap="square" lIns="0" tIns="0" rIns="0" bIns="0" rtlCol="0" anchor="ctr"/>
+          <a:lstStyle/>
+          <a:p>
+            <a:pPr algn="ctr" indent="0" marL="0">
+              <a:buNone/>
+            </a:pPr>
+            <a:r>
+              <a:rPr lang="en-US" sz="1150" b="1" dirty="0">
+                <a:solidFill>
+                  <a:srgbClr val="1B2440"/>
+                </a:solidFill>
+                <a:latin typeface="Calibri" pitchFamily="34" charset="0"/>
+                <a:ea typeface="Calibri" pitchFamily="34" charset="-122"/>
+                <a:cs typeface="Calibri" pitchFamily="34" charset="-120"/>
+              </a:rPr>
+              <a:t>RAG + логи</a:t>
+            </a:r>
+            <a:endParaRPr lang="en-US" sz="1150" dirty="0"/>
+          </a:p>
+        </p:txBody>
+      </p:sp>
+      <p:sp>
+        <p:nvSpPr>
+          <p:cNvPr id="17" name="Text 15"/>
+          <p:cNvSpPr/>
+          <p:nvPr/>
+        </p:nvSpPr>
+        <p:spPr>
+          <a:xfrm>
+            <a:off x="3328416" y="2468880"/>
+            <a:ext cx="1115568" cy="685800"/>
+          </a:xfrm>
+          <a:prstGeom prst="rect">
+            <a:avLst/>
+          </a:prstGeom>
+          <a:noFill/>
+          <a:ln/>
+        </p:spPr>
+        <p:txBody>
+          <a:bodyPr wrap="square" lIns="0" tIns="0" rIns="0" bIns="0" rtlCol="0" anchor="ctr"/>
+          <a:lstStyle/>
+          <a:p>
+            <a:pPr algn="ctr" indent="0" marL="0">
+              <a:buNone/>
+            </a:pPr>
+            <a:r>
+              <a:rPr lang="en-US" sz="1050" dirty="0">
+                <a:solidFill>
+                  <a:srgbClr val="6B7280"/>
+                </a:solidFill>
+                <a:latin typeface="Calibri" pitchFamily="34" charset="0"/>
+                <a:ea typeface="Calibri" pitchFamily="34" charset="-122"/>
+                <a:cs typeface="Calibri" pitchFamily="34" charset="-120"/>
+              </a:rPr>
+              <a:t>embeddinggemma + Atlas Vector Search; траси подій</a:t>
+            </a:r>
+            <a:endParaRPr lang="en-US" sz="1050" dirty="0"/>
+          </a:p>
+        </p:txBody>
+      </p:sp>
+      <p:sp>
+        <p:nvSpPr>
+          <p:cNvPr id="18" name="Shape 16"/>
+          <p:cNvSpPr/>
+          <p:nvPr/>
+        </p:nvSpPr>
+        <p:spPr>
+          <a:xfrm>
+            <a:off x="4654296" y="1417320"/>
+            <a:ext cx="1261872" cy="1828800"/>
+          </a:xfrm>
+          <a:prstGeom prst="roundRect">
+            <a:avLst>
+              <a:gd name="adj" fmla="val 8696"/>
+            </a:avLst>
+          </a:prstGeom>
+          <a:solidFill>
+            <a:srgbClr val="F4F6FA"/>
+          </a:solidFill>
+          <a:ln/>
+          <a:effectLst>
+            <a:outerShdw sx="100000" sy="100000" kx="0" ky="0" algn="bl" rotWithShape="0" blurRad="76200" dist="25400" dir="5400000">
+              <a:srgbClr val="000000">
+                <a:alpha val="12000"/>
+              </a:srgbClr>
+            </a:outerShdw>
+          </a:effectLst>
+        </p:spPr>
+      </p:sp>
+      <p:sp>
+        <p:nvSpPr>
+          <p:cNvPr id="19" name="Shape 17"/>
+          <p:cNvSpPr/>
+          <p:nvPr/>
+        </p:nvSpPr>
+        <p:spPr>
+          <a:xfrm>
+            <a:off x="5056632" y="1554480"/>
+            <a:ext cx="457200" cy="457200"/>
+          </a:xfrm>
+          <a:prstGeom prst="ellipse">
+            <a:avLst/>
+          </a:prstGeom>
+          <a:solidFill>
+            <a:srgbClr val="D7DEEA"/>
+          </a:solidFill>
+          <a:ln/>
+        </p:spPr>
+      </p:sp>
+      <p:sp>
+        <p:nvSpPr>
+          <p:cNvPr id="20" name="Text 18"/>
+          <p:cNvSpPr/>
+          <p:nvPr/>
+        </p:nvSpPr>
+        <p:spPr>
+          <a:xfrm>
+            <a:off x="5056632" y="1554480"/>
+            <a:ext cx="457200" cy="457200"/>
+          </a:xfrm>
+          <a:prstGeom prst="rect">
+            <a:avLst/>
+          </a:prstGeom>
+          <a:noFill/>
+          <a:ln/>
+        </p:spPr>
+        <p:txBody>
+          <a:bodyPr wrap="square" lIns="0" tIns="0" rIns="0" bIns="0" rtlCol="0" anchor="ctr"/>
+          <a:lstStyle/>
+          <a:p>
+            <a:pPr algn="ctr" indent="0" marL="0">
+              <a:buNone/>
+            </a:pPr>
+            <a:r>
+              <a:rPr lang="en-US" sz="1600" b="1" dirty="0">
+                <a:solidFill>
+                  <a:srgbClr val="1B2440"/>
+                </a:solidFill>
+                <a:latin typeface="Calibri" pitchFamily="34" charset="0"/>
+                <a:ea typeface="Calibri" pitchFamily="34" charset="-122"/>
+                <a:cs typeface="Calibri" pitchFamily="34" charset="-120"/>
+              </a:rPr>
+              <a:t>4</a:t>
+            </a:r>
+            <a:endParaRPr lang="en-US" sz="1600" dirty="0"/>
+          </a:p>
+        </p:txBody>
+      </p:sp>
+      <p:sp>
+        <p:nvSpPr>
+          <p:cNvPr id="21" name="Text 19"/>
+          <p:cNvSpPr/>
+          <p:nvPr/>
+        </p:nvSpPr>
+        <p:spPr>
+          <a:xfrm>
+            <a:off x="4727448" y="2103120"/>
+            <a:ext cx="1115568" cy="365760"/>
+          </a:xfrm>
+          <a:prstGeom prst="rect">
+            <a:avLst/>
+          </a:prstGeom>
+          <a:noFill/>
+          <a:ln/>
+        </p:spPr>
+        <p:txBody>
+          <a:bodyPr wrap="square" lIns="0" tIns="0" rIns="0" bIns="0" rtlCol="0" anchor="ctr"/>
+          <a:lstStyle/>
+          <a:p>
+            <a:pPr algn="ctr" indent="0" marL="0">
+              <a:buNone/>
+            </a:pPr>
+            <a:r>
+              <a:rPr lang="en-US" sz="1150" b="1" dirty="0">
+                <a:solidFill>
+                  <a:srgbClr val="1B2440"/>
+                </a:solidFill>
+                <a:latin typeface="Calibri" pitchFamily="34" charset="0"/>
+                <a:ea typeface="Calibri" pitchFamily="34" charset="-122"/>
+                <a:cs typeface="Calibri" pitchFamily="34" charset="-120"/>
+              </a:rPr>
+              <a:t>Пропозиція</a:t>
+            </a:r>
+            <a:endParaRPr lang="en-US" sz="1150" dirty="0"/>
+          </a:p>
+        </p:txBody>
+      </p:sp>
+      <p:sp>
+        <p:nvSpPr>
+          <p:cNvPr id="22" name="Text 20"/>
+          <p:cNvSpPr/>
+          <p:nvPr/>
+        </p:nvSpPr>
+        <p:spPr>
+          <a:xfrm>
+            <a:off x="4727448" y="2468880"/>
+            <a:ext cx="1115568" cy="685800"/>
+          </a:xfrm>
+          <a:prstGeom prst="rect">
+            <a:avLst/>
+          </a:prstGeom>
+          <a:noFill/>
+          <a:ln/>
+        </p:spPr>
+        <p:txBody>
+          <a:bodyPr wrap="square" lIns="0" tIns="0" rIns="0" bIns="0" rtlCol="0" anchor="ctr"/>
+          <a:lstStyle/>
+          <a:p>
+            <a:pPr algn="ctr" indent="0" marL="0">
+              <a:buNone/>
+            </a:pPr>
+            <a:r>
+              <a:rPr lang="en-US" sz="1050" dirty="0">
+                <a:solidFill>
+                  <a:srgbClr val="6B7280"/>
+                </a:solidFill>
+                <a:latin typeface="Calibri" pitchFamily="34" charset="0"/>
+                <a:ea typeface="Calibri" pitchFamily="34" charset="-122"/>
+                <a:cs typeface="Calibri" pitchFamily="34" charset="-120"/>
+              </a:rPr>
+              <a:t>дія з превʼю і сумою</a:t>
+            </a:r>
+            <a:endParaRPr lang="en-US" sz="1050" dirty="0"/>
+          </a:p>
+        </p:txBody>
+      </p:sp>
+      <p:sp>
+        <p:nvSpPr>
+          <p:cNvPr id="23" name="Shape 21"/>
+          <p:cNvSpPr/>
+          <p:nvPr/>
+        </p:nvSpPr>
+        <p:spPr>
+          <a:xfrm>
+            <a:off x="6053328" y="1417320"/>
+            <a:ext cx="1261872" cy="1828800"/>
+          </a:xfrm>
+          <a:prstGeom prst="roundRect">
+            <a:avLst>
+              <a:gd name="adj" fmla="val 8696"/>
+            </a:avLst>
+          </a:prstGeom>
+          <a:solidFill>
+            <a:srgbClr val="FFF4E0"/>
+          </a:solidFill>
+          <a:ln/>
+          <a:effectLst>
+            <a:outerShdw sx="100000" sy="100000" kx="0" ky="0" algn="bl" rotWithShape="0" blurRad="76200" dist="25400" dir="5400000">
+              <a:srgbClr val="000000">
+                <a:alpha val="12000"/>
+              </a:srgbClr>
+            </a:outerShdw>
+          </a:effectLst>
+        </p:spPr>
+      </p:sp>
+      <p:sp>
+        <p:nvSpPr>
+          <p:cNvPr id="24" name="Shape 22"/>
+          <p:cNvSpPr/>
+          <p:nvPr/>
+        </p:nvSpPr>
+        <p:spPr>
+          <a:xfrm>
+            <a:off x="6455664" y="1554480"/>
+            <a:ext cx="457200" cy="457200"/>
           </a:xfrm>
           <a:prstGeom prst="ellipse">
             <a:avLst/>
@@ -4007,30 +4175,313 @@
       </p:sp>
       <p:sp>
         <p:nvSpPr>
-          <p:cNvPr id="13" name="Text 11"/>
-          <p:cNvSpPr/>
-          <p:nvPr/>
-        </p:nvSpPr>
-        <p:spPr>
-          <a:xfrm>
-            <a:off x="6263640" y="2011680"/>
-            <a:ext cx="2194560" cy="685800"/>
-          </a:xfrm>
-          <a:prstGeom prst="rect">
-            <a:avLst/>
-          </a:prstGeom>
-          <a:noFill/>
-          <a:ln/>
-        </p:spPr>
-        <p:txBody>
-          <a:bodyPr wrap="square" lIns="0" tIns="0" rIns="0" bIns="0" rtlCol="0" anchor="t"/>
+          <p:cNvPr id="25" name="Text 23"/>
+          <p:cNvSpPr/>
+          <p:nvPr/>
+        </p:nvSpPr>
+        <p:spPr>
+          <a:xfrm>
+            <a:off x="6455664" y="1554480"/>
+            <a:ext cx="457200" cy="457200"/>
+          </a:xfrm>
+          <a:prstGeom prst="rect">
+            <a:avLst/>
+          </a:prstGeom>
+          <a:noFill/>
+          <a:ln/>
+        </p:spPr>
+        <p:txBody>
+          <a:bodyPr wrap="square" lIns="0" tIns="0" rIns="0" bIns="0" rtlCol="0" anchor="ctr"/>
+          <a:lstStyle/>
+          <a:p>
+            <a:pPr algn="ctr" indent="0" marL="0">
+              <a:buNone/>
+            </a:pPr>
+            <a:r>
+              <a:rPr lang="en-US" sz="1600" b="1" dirty="0">
+                <a:solidFill>
+                  <a:srgbClr val="1B2440"/>
+                </a:solidFill>
+                <a:latin typeface="Calibri" pitchFamily="34" charset="0"/>
+                <a:ea typeface="Calibri" pitchFamily="34" charset="-122"/>
+                <a:cs typeface="Calibri" pitchFamily="34" charset="-120"/>
+              </a:rPr>
+              <a:t>5</a:t>
+            </a:r>
+            <a:endParaRPr lang="en-US" sz="1600" dirty="0"/>
+          </a:p>
+        </p:txBody>
+      </p:sp>
+      <p:sp>
+        <p:nvSpPr>
+          <p:cNvPr id="26" name="Text 24"/>
+          <p:cNvSpPr/>
+          <p:nvPr/>
+        </p:nvSpPr>
+        <p:spPr>
+          <a:xfrm>
+            <a:off x="6126480" y="2103120"/>
+            <a:ext cx="1115568" cy="365760"/>
+          </a:xfrm>
+          <a:prstGeom prst="rect">
+            <a:avLst/>
+          </a:prstGeom>
+          <a:noFill/>
+          <a:ln/>
+        </p:spPr>
+        <p:txBody>
+          <a:bodyPr wrap="square" lIns="0" tIns="0" rIns="0" bIns="0" rtlCol="0" anchor="ctr"/>
+          <a:lstStyle/>
+          <a:p>
+            <a:pPr algn="ctr" indent="0" marL="0">
+              <a:buNone/>
+            </a:pPr>
+            <a:r>
+              <a:rPr lang="en-US" sz="1150" b="1" dirty="0">
+                <a:solidFill>
+                  <a:srgbClr val="1B2440"/>
+                </a:solidFill>
+                <a:latin typeface="Calibri" pitchFamily="34" charset="0"/>
+                <a:ea typeface="Calibri" pitchFamily="34" charset="-122"/>
+                <a:cs typeface="Calibri" pitchFamily="34" charset="-120"/>
+              </a:rPr>
+              <a:t>Підтвердження</a:t>
+            </a:r>
+            <a:endParaRPr lang="en-US" sz="1150" dirty="0"/>
+          </a:p>
+        </p:txBody>
+      </p:sp>
+      <p:sp>
+        <p:nvSpPr>
+          <p:cNvPr id="27" name="Text 25"/>
+          <p:cNvSpPr/>
+          <p:nvPr/>
+        </p:nvSpPr>
+        <p:spPr>
+          <a:xfrm>
+            <a:off x="6126480" y="2468880"/>
+            <a:ext cx="1115568" cy="685800"/>
+          </a:xfrm>
+          <a:prstGeom prst="rect">
+            <a:avLst/>
+          </a:prstGeom>
+          <a:noFill/>
+          <a:ln/>
+        </p:spPr>
+        <p:txBody>
+          <a:bodyPr wrap="square" lIns="0" tIns="0" rIns="0" bIns="0" rtlCol="0" anchor="ctr"/>
+          <a:lstStyle/>
+          <a:p>
+            <a:pPr algn="ctr" indent="0" marL="0">
+              <a:buNone/>
+            </a:pPr>
+            <a:r>
+              <a:rPr lang="en-US" sz="1050" dirty="0">
+                <a:solidFill>
+                  <a:srgbClr val="6B7280"/>
+                </a:solidFill>
+                <a:latin typeface="Calibri" pitchFamily="34" charset="0"/>
+                <a:ea typeface="Calibri" pitchFamily="34" charset="-122"/>
+                <a:cs typeface="Calibri" pitchFamily="34" charset="-120"/>
+              </a:rPr>
+              <a:t>лише власник, одним кліком</a:t>
+            </a:r>
+            <a:endParaRPr lang="en-US" sz="1050" dirty="0"/>
+          </a:p>
+        </p:txBody>
+      </p:sp>
+      <p:sp>
+        <p:nvSpPr>
+          <p:cNvPr id="28" name="Shape 26"/>
+          <p:cNvSpPr/>
+          <p:nvPr/>
+        </p:nvSpPr>
+        <p:spPr>
+          <a:xfrm>
+            <a:off x="7452360" y="1417320"/>
+            <a:ext cx="1261872" cy="1828800"/>
+          </a:xfrm>
+          <a:prstGeom prst="roundRect">
+            <a:avLst>
+              <a:gd name="adj" fmla="val 8696"/>
+            </a:avLst>
+          </a:prstGeom>
+          <a:solidFill>
+            <a:srgbClr val="F4F6FA"/>
+          </a:solidFill>
+          <a:ln/>
+          <a:effectLst>
+            <a:outerShdw sx="100000" sy="100000" kx="0" ky="0" algn="bl" rotWithShape="0" blurRad="76200" dist="25400" dir="5400000">
+              <a:srgbClr val="000000">
+                <a:alpha val="12000"/>
+              </a:srgbClr>
+            </a:outerShdw>
+          </a:effectLst>
+        </p:spPr>
+      </p:sp>
+      <p:sp>
+        <p:nvSpPr>
+          <p:cNvPr id="29" name="Shape 27"/>
+          <p:cNvSpPr/>
+          <p:nvPr/>
+        </p:nvSpPr>
+        <p:spPr>
+          <a:xfrm>
+            <a:off x="7854696" y="1554480"/>
+            <a:ext cx="457200" cy="457200"/>
+          </a:xfrm>
+          <a:prstGeom prst="ellipse">
+            <a:avLst/>
+          </a:prstGeom>
+          <a:solidFill>
+            <a:srgbClr val="D7DEEA"/>
+          </a:solidFill>
+          <a:ln/>
+        </p:spPr>
+      </p:sp>
+      <p:sp>
+        <p:nvSpPr>
+          <p:cNvPr id="30" name="Text 28"/>
+          <p:cNvSpPr/>
+          <p:nvPr/>
+        </p:nvSpPr>
+        <p:spPr>
+          <a:xfrm>
+            <a:off x="7854696" y="1554480"/>
+            <a:ext cx="457200" cy="457200"/>
+          </a:xfrm>
+          <a:prstGeom prst="rect">
+            <a:avLst/>
+          </a:prstGeom>
+          <a:noFill/>
+          <a:ln/>
+        </p:spPr>
+        <p:txBody>
+          <a:bodyPr wrap="square" lIns="0" tIns="0" rIns="0" bIns="0" rtlCol="0" anchor="ctr"/>
+          <a:lstStyle/>
+          <a:p>
+            <a:pPr algn="ctr" indent="0" marL="0">
+              <a:buNone/>
+            </a:pPr>
+            <a:r>
+              <a:rPr lang="en-US" sz="1600" b="1" dirty="0">
+                <a:solidFill>
+                  <a:srgbClr val="1B2440"/>
+                </a:solidFill>
+                <a:latin typeface="Calibri" pitchFamily="34" charset="0"/>
+                <a:ea typeface="Calibri" pitchFamily="34" charset="-122"/>
+                <a:cs typeface="Calibri" pitchFamily="34" charset="-120"/>
+              </a:rPr>
+              <a:t>6</a:t>
+            </a:r>
+            <a:endParaRPr lang="en-US" sz="1600" dirty="0"/>
+          </a:p>
+        </p:txBody>
+      </p:sp>
+      <p:sp>
+        <p:nvSpPr>
+          <p:cNvPr id="31" name="Text 29"/>
+          <p:cNvSpPr/>
+          <p:nvPr/>
+        </p:nvSpPr>
+        <p:spPr>
+          <a:xfrm>
+            <a:off x="7525512" y="2103120"/>
+            <a:ext cx="1115568" cy="365760"/>
+          </a:xfrm>
+          <a:prstGeom prst="rect">
+            <a:avLst/>
+          </a:prstGeom>
+          <a:noFill/>
+          <a:ln/>
+        </p:spPr>
+        <p:txBody>
+          <a:bodyPr wrap="square" lIns="0" tIns="0" rIns="0" bIns="0" rtlCol="0" anchor="ctr"/>
+          <a:lstStyle/>
+          <a:p>
+            <a:pPr algn="ctr" indent="0" marL="0">
+              <a:buNone/>
+            </a:pPr>
+            <a:r>
+              <a:rPr lang="en-US" sz="1150" b="1" dirty="0">
+                <a:solidFill>
+                  <a:srgbClr val="1B2440"/>
+                </a:solidFill>
+                <a:latin typeface="Calibri" pitchFamily="34" charset="0"/>
+                <a:ea typeface="Calibri" pitchFamily="34" charset="-122"/>
+                <a:cs typeface="Calibri" pitchFamily="34" charset="-120"/>
+              </a:rPr>
+              <a:t>Виконання</a:t>
+            </a:r>
+            <a:endParaRPr lang="en-US" sz="1150" dirty="0"/>
+          </a:p>
+        </p:txBody>
+      </p:sp>
+      <p:sp>
+        <p:nvSpPr>
+          <p:cNvPr id="32" name="Text 30"/>
+          <p:cNvSpPr/>
+          <p:nvPr/>
+        </p:nvSpPr>
+        <p:spPr>
+          <a:xfrm>
+            <a:off x="7525512" y="2468880"/>
+            <a:ext cx="1115568" cy="685800"/>
+          </a:xfrm>
+          <a:prstGeom prst="rect">
+            <a:avLst/>
+          </a:prstGeom>
+          <a:noFill/>
+          <a:ln/>
+        </p:spPr>
+        <p:txBody>
+          <a:bodyPr wrap="square" lIns="0" tIns="0" rIns="0" bIns="0" rtlCol="0" anchor="ctr"/>
+          <a:lstStyle/>
+          <a:p>
+            <a:pPr algn="ctr" indent="0" marL="0">
+              <a:buNone/>
+            </a:pPr>
+            <a:r>
+              <a:rPr lang="en-US" sz="1050" dirty="0">
+                <a:solidFill>
+                  <a:srgbClr val="6B7280"/>
+                </a:solidFill>
+                <a:latin typeface="Calibri" pitchFamily="34" charset="0"/>
+                <a:ea typeface="Calibri" pitchFamily="34" charset="-122"/>
+                <a:cs typeface="Calibri" pitchFamily="34" charset="-120"/>
+              </a:rPr>
+              <a:t>атомарно, з перевіркою і аудитом</a:t>
+            </a:r>
+            <a:endParaRPr lang="en-US" sz="1050" dirty="0"/>
+          </a:p>
+        </p:txBody>
+      </p:sp>
+      <p:sp>
+        <p:nvSpPr>
+          <p:cNvPr id="33" name="Text 31"/>
+          <p:cNvSpPr/>
+          <p:nvPr/>
+        </p:nvSpPr>
+        <p:spPr>
+          <a:xfrm>
+            <a:off x="457200" y="3657600"/>
+            <a:ext cx="8229600" cy="548640"/>
+          </a:xfrm>
+          <a:prstGeom prst="rect">
+            <a:avLst/>
+          </a:prstGeom>
+          <a:noFill/>
+          <a:ln/>
+        </p:spPr>
+        <p:txBody>
+          <a:bodyPr wrap="square" lIns="0" tIns="0" rIns="0" bIns="0" rtlCol="0" anchor="ctr"/>
           <a:lstStyle/>
           <a:p>
             <a:pPr indent="0" marL="0">
               <a:buNone/>
             </a:pPr>
             <a:r>
-              <a:rPr lang="en-US" sz="1500" b="1" dirty="0">
+              <a:rPr lang="en-US" sz="1500" i="1" dirty="0">
                 <a:solidFill>
                   <a:srgbClr val="1B2440"/>
                 </a:solidFill>
@@ -4038,48 +4489,9 @@
                 <a:ea typeface="Calibri" pitchFamily="34" charset="-122"/>
                 <a:cs typeface="Calibri" pitchFamily="34" charset="-120"/>
               </a:rPr>
-              <a:t>Створи промокод -10% до 10 листопада</a:t>
+              <a:t>Модель лише читає і пропонує. Гроші, права і ізоляція клієнтів контролюються кодом, а не промптом.</a:t>
             </a:r>
             <a:endParaRPr lang="en-US" sz="1500" dirty="0"/>
-          </a:p>
-        </p:txBody>
-      </p:sp>
-      <p:sp>
-        <p:nvSpPr>
-          <p:cNvPr id="14" name="Text 12"/>
-          <p:cNvSpPr/>
-          <p:nvPr/>
-        </p:nvSpPr>
-        <p:spPr>
-          <a:xfrm>
-            <a:off x="6263640" y="2743200"/>
-            <a:ext cx="2194560" cy="1463040"/>
-          </a:xfrm>
-          <a:prstGeom prst="rect">
-            <a:avLst/>
-          </a:prstGeom>
-          <a:noFill/>
-          <a:ln/>
-        </p:spPr>
-        <p:txBody>
-          <a:bodyPr wrap="square" lIns="0" tIns="0" rIns="0" bIns="0" rtlCol="0" anchor="t"/>
-          <a:lstStyle/>
-          <a:p>
-            <a:pPr indent="0" marL="0">
-              <a:buNone/>
-            </a:pPr>
-            <a:r>
-              <a:rPr lang="en-US" sz="1150" dirty="0">
-                <a:solidFill>
-                  <a:srgbClr val="6B7280"/>
-                </a:solidFill>
-                <a:latin typeface="Calibri" pitchFamily="34" charset="0"/>
-                <a:ea typeface="Calibri" pitchFamily="34" charset="-122"/>
-                <a:cs typeface="Calibri" pitchFamily="34" charset="-120"/>
-              </a:rPr>
-              <a:t>Уточнює ліміт використань, показує превʼю, створює промокод після підтвердження.</a:t>
-            </a:r>
-            <a:endParaRPr lang="en-US" sz="1150" dirty="0"/>
           </a:p>
         </p:txBody>
       </p:sp>
@@ -4567,42 +4979,26 @@
                 <a:ea typeface="Cambria" pitchFamily="34" charset="-122"/>
                 <a:cs typeface="Cambria" pitchFamily="34" charset="-120"/>
               </a:rPr>
-              <a:t>Цінність для компанії-розробника</a:t>
+              <a:t>Живе демо: три типові звернення</a:t>
             </a:r>
             <a:endParaRPr lang="en-US" sz="3000" dirty="0"/>
           </a:p>
         </p:txBody>
       </p:sp>
-      <p:graphicFrame>
-        <p:nvGraphicFramePr>
-          <p:cNvPr id="3" name="Chart 0" descr=""/>
-          <p:cNvGraphicFramePr/>
-          <p:nvPr/>
-        </p:nvGraphicFramePr>
-        <p:xfrm>
-          <a:off x="365760" y="1143000"/>
-          <a:ext cx="4206240" cy="3108960"/>
-        </p:xfrm>
-        <a:graphic xmlns:a="http://schemas.openxmlformats.org/drawingml/2006/main">
-          <a:graphicData uri="http://schemas.openxmlformats.org/drawingml/2006/chart">
-            <c:chart xmlns:c="http://schemas.openxmlformats.org/drawingml/2006/chart" r:id="rId1"/>
-          </a:graphicData>
-        </a:graphic>
-      </p:graphicFrame>
-      <p:sp>
-        <p:nvSpPr>
-          <p:cNvPr id="4" name="Shape 1"/>
-          <p:cNvSpPr/>
-          <p:nvPr/>
-        </p:nvSpPr>
-        <p:spPr>
-          <a:xfrm>
-            <a:off x="4846320" y="1188720"/>
-            <a:ext cx="3840480" cy="841248"/>
+      <p:sp>
+        <p:nvSpPr>
+          <p:cNvPr id="3" name="Shape 1"/>
+          <p:cNvSpPr/>
+          <p:nvPr/>
+        </p:nvSpPr>
+        <p:spPr>
+          <a:xfrm>
+            <a:off x="457200" y="1188720"/>
+            <a:ext cx="2606040" cy="2697480"/>
           </a:xfrm>
           <a:prstGeom prst="roundRect">
             <a:avLst>
-              <a:gd name="adj" fmla="val 13043"/>
+              <a:gd name="adj" fmla="val 4211"/>
             </a:avLst>
           </a:prstGeom>
           <a:solidFill>
@@ -4620,69 +5016,89 @@
       </p:sp>
       <p:sp>
         <p:nvSpPr>
-          <p:cNvPr id="5" name="Text 2"/>
-          <p:cNvSpPr/>
-          <p:nvPr/>
-        </p:nvSpPr>
-        <p:spPr>
-          <a:xfrm>
-            <a:off x="5029200" y="1261872"/>
-            <a:ext cx="3566160" cy="438912"/>
-          </a:xfrm>
-          <a:prstGeom prst="rect">
-            <a:avLst/>
-          </a:prstGeom>
-          <a:noFill/>
-          <a:ln/>
-        </p:spPr>
-        <p:txBody>
-          <a:bodyPr wrap="square" lIns="0" tIns="0" rIns="0" bIns="0" rtlCol="0" anchor="ctr"/>
+          <p:cNvPr id="4" name="Shape 2"/>
+          <p:cNvSpPr/>
+          <p:nvPr/>
+        </p:nvSpPr>
+        <p:spPr>
+          <a:xfrm>
+            <a:off x="685800" y="1325880"/>
+            <a:ext cx="411480" cy="411480"/>
+          </a:xfrm>
+          <a:prstGeom prst="ellipse">
+            <a:avLst/>
+          </a:prstGeom>
+          <a:solidFill>
+            <a:srgbClr val="2A9D8F"/>
+          </a:solidFill>
+          <a:ln/>
+        </p:spPr>
+      </p:sp>
+      <p:sp>
+        <p:nvSpPr>
+          <p:cNvPr id="5" name="Text 3"/>
+          <p:cNvSpPr/>
+          <p:nvPr/>
+        </p:nvSpPr>
+        <p:spPr>
+          <a:xfrm>
+            <a:off x="685800" y="1810512"/>
+            <a:ext cx="2194560" cy="640080"/>
+          </a:xfrm>
+          <a:prstGeom prst="rect">
+            <a:avLst/>
+          </a:prstGeom>
+          <a:noFill/>
+          <a:ln/>
+        </p:spPr>
+        <p:txBody>
+          <a:bodyPr wrap="square" lIns="0" tIns="0" rIns="0" bIns="0" rtlCol="0" anchor="t"/>
           <a:lstStyle/>
           <a:p>
             <a:pPr indent="0" marL="0">
               <a:buNone/>
             </a:pPr>
             <a:r>
-              <a:rPr lang="en-US" sz="2400" b="1" dirty="0">
+              <a:rPr lang="en-US" sz="1500" b="1" dirty="0">
                 <a:solidFill>
                   <a:srgbClr val="1B2440"/>
                 </a:solidFill>
-                <a:latin typeface="Cambria" pitchFamily="34" charset="0"/>
-                <a:ea typeface="Cambria" pitchFamily="34" charset="-122"/>
-                <a:cs typeface="Cambria" pitchFamily="34" charset="-120"/>
-              </a:rPr>
-              <a:t>−150 год</a:t>
-            </a:r>
-            <a:endParaRPr lang="en-US" sz="2400" dirty="0"/>
-          </a:p>
-        </p:txBody>
-      </p:sp>
-      <p:sp>
-        <p:nvSpPr>
-          <p:cNvPr id="6" name="Text 3"/>
-          <p:cNvSpPr/>
-          <p:nvPr/>
-        </p:nvSpPr>
-        <p:spPr>
-          <a:xfrm>
-            <a:off x="5029200" y="1691640"/>
-            <a:ext cx="3566160" cy="274320"/>
-          </a:xfrm>
-          <a:prstGeom prst="rect">
-            <a:avLst/>
-          </a:prstGeom>
-          <a:noFill/>
-          <a:ln/>
-        </p:spPr>
-        <p:txBody>
-          <a:bodyPr wrap="square" lIns="0" tIns="0" rIns="0" bIns="0" rtlCol="0" anchor="ctr"/>
+                <a:latin typeface="Calibri" pitchFamily="34" charset="0"/>
+                <a:ea typeface="Calibri" pitchFamily="34" charset="-122"/>
+                <a:cs typeface="Calibri" pitchFamily="34" charset="-120"/>
+              </a:rPr>
+              <a:t>Промокод не працює на касі</a:t>
+            </a:r>
+            <a:endParaRPr lang="en-US" sz="1500" dirty="0"/>
+          </a:p>
+        </p:txBody>
+      </p:sp>
+      <p:sp>
+        <p:nvSpPr>
+          <p:cNvPr id="6" name="Text 4"/>
+          <p:cNvSpPr/>
+          <p:nvPr/>
+        </p:nvSpPr>
+        <p:spPr>
+          <a:xfrm>
+            <a:off x="685800" y="2468880"/>
+            <a:ext cx="2194560" cy="1371600"/>
+          </a:xfrm>
+          <a:prstGeom prst="rect">
+            <a:avLst/>
+          </a:prstGeom>
+          <a:noFill/>
+          <a:ln/>
+        </p:spPr>
+        <p:txBody>
+          <a:bodyPr wrap="square" lIns="0" tIns="0" rIns="0" bIns="0" rtlCol="0" anchor="t"/>
           <a:lstStyle/>
           <a:p>
             <a:pPr indent="0" marL="0">
               <a:buNone/>
             </a:pPr>
             <a:r>
-              <a:rPr lang="en-US" sz="1200" dirty="0">
+              <a:rPr lang="en-US" sz="1150" dirty="0">
                 <a:solidFill>
                   <a:srgbClr val="6B7280"/>
                 </a:solidFill>
@@ -4690,26 +5106,26 @@
                 <a:ea typeface="Calibri" pitchFamily="34" charset="-122"/>
                 <a:cs typeface="Calibri" pitchFamily="34" charset="-120"/>
               </a:rPr>
-              <a:t>на місяць ≈ 0,9 FTE</a:t>
-            </a:r>
-            <a:endParaRPr lang="en-US" sz="1200" dirty="0"/>
-          </a:p>
-        </p:txBody>
-      </p:sp>
-      <p:sp>
-        <p:nvSpPr>
-          <p:cNvPr id="7" name="Shape 4"/>
-          <p:cNvSpPr/>
-          <p:nvPr/>
-        </p:nvSpPr>
-        <p:spPr>
-          <a:xfrm>
-            <a:off x="4846320" y="2176272"/>
-            <a:ext cx="3840480" cy="841248"/>
+              <a:t>Gemma знаходить POS_SYNC_FAILED у трасі, бачить версію 6 замість 7, пропонує resync_pos. Після підтвердження чек проходить.</a:t>
+            </a:r>
+            <a:endParaRPr lang="en-US" sz="1150" dirty="0"/>
+          </a:p>
+        </p:txBody>
+      </p:sp>
+      <p:sp>
+        <p:nvSpPr>
+          <p:cNvPr id="7" name="Shape 5"/>
+          <p:cNvSpPr/>
+          <p:nvPr/>
+        </p:nvSpPr>
+        <p:spPr>
+          <a:xfrm>
+            <a:off x="3246120" y="1188720"/>
+            <a:ext cx="2606040" cy="2697480"/>
           </a:xfrm>
           <a:prstGeom prst="roundRect">
             <a:avLst>
-              <a:gd name="adj" fmla="val 13043"/>
+              <a:gd name="adj" fmla="val 4211"/>
             </a:avLst>
           </a:prstGeom>
           <a:solidFill>
@@ -4727,69 +5143,89 @@
       </p:sp>
       <p:sp>
         <p:nvSpPr>
-          <p:cNvPr id="8" name="Text 5"/>
-          <p:cNvSpPr/>
-          <p:nvPr/>
-        </p:nvSpPr>
-        <p:spPr>
-          <a:xfrm>
-            <a:off x="5029200" y="2249424"/>
-            <a:ext cx="3566160" cy="438912"/>
-          </a:xfrm>
-          <a:prstGeom prst="rect">
-            <a:avLst/>
-          </a:prstGeom>
-          <a:noFill/>
-          <a:ln/>
-        </p:spPr>
-        <p:txBody>
-          <a:bodyPr wrap="square" lIns="0" tIns="0" rIns="0" bIns="0" rtlCol="0" anchor="ctr"/>
+          <p:cNvPr id="8" name="Shape 6"/>
+          <p:cNvSpPr/>
+          <p:nvPr/>
+        </p:nvSpPr>
+        <p:spPr>
+          <a:xfrm>
+            <a:off x="3474720" y="1325880"/>
+            <a:ext cx="411480" cy="411480"/>
+          </a:xfrm>
+          <a:prstGeom prst="ellipse">
+            <a:avLst/>
+          </a:prstGeom>
+          <a:solidFill>
+            <a:srgbClr val="C8553D"/>
+          </a:solidFill>
+          <a:ln/>
+        </p:spPr>
+      </p:sp>
+      <p:sp>
+        <p:nvSpPr>
+          <p:cNvPr id="9" name="Text 7"/>
+          <p:cNvSpPr/>
+          <p:nvPr/>
+        </p:nvSpPr>
+        <p:spPr>
+          <a:xfrm>
+            <a:off x="3474720" y="1810512"/>
+            <a:ext cx="2194560" cy="640080"/>
+          </a:xfrm>
+          <a:prstGeom prst="rect">
+            <a:avLst/>
+          </a:prstGeom>
+          <a:noFill/>
+          <a:ln/>
+        </p:spPr>
+        <p:txBody>
+          <a:bodyPr wrap="square" lIns="0" tIns="0" rIns="0" bIns="0" rtlCol="0" anchor="t"/>
           <a:lstStyle/>
           <a:p>
             <a:pPr indent="0" marL="0">
               <a:buNone/>
             </a:pPr>
             <a:r>
-              <a:rPr lang="en-US" sz="2400" b="1" dirty="0">
+              <a:rPr lang="en-US" sz="1500" b="1" dirty="0">
                 <a:solidFill>
                   <a:srgbClr val="1B2440"/>
                 </a:solidFill>
-                <a:latin typeface="Cambria" pitchFamily="34" charset="0"/>
-                <a:ea typeface="Cambria" pitchFamily="34" charset="-122"/>
-                <a:cs typeface="Cambria" pitchFamily="34" charset="-120"/>
-              </a:rPr>
-              <a:t>≈ 28 500 грн</a:t>
-            </a:r>
-            <a:endParaRPr lang="en-US" sz="2400" dirty="0"/>
-          </a:p>
-        </p:txBody>
-      </p:sp>
-      <p:sp>
-        <p:nvSpPr>
-          <p:cNvPr id="9" name="Text 6"/>
-          <p:cNvSpPr/>
-          <p:nvPr/>
-        </p:nvSpPr>
-        <p:spPr>
-          <a:xfrm>
-            <a:off x="5029200" y="2679192"/>
-            <a:ext cx="3566160" cy="274320"/>
-          </a:xfrm>
-          <a:prstGeom prst="rect">
-            <a:avLst/>
-          </a:prstGeom>
-          <a:noFill/>
-          <a:ln/>
-        </p:spPr>
-        <p:txBody>
-          <a:bodyPr wrap="square" lIns="0" tIns="0" rIns="0" bIns="0" rtlCol="0" anchor="ctr"/>
+                <a:latin typeface="Calibri" pitchFamily="34" charset="0"/>
+                <a:ea typeface="Calibri" pitchFamily="34" charset="-122"/>
+                <a:cs typeface="Calibri" pitchFamily="34" charset="-120"/>
+              </a:rPr>
+              <a:t>З мене списали двічі</a:t>
+            </a:r>
+            <a:endParaRPr lang="en-US" sz="1500" dirty="0"/>
+          </a:p>
+        </p:txBody>
+      </p:sp>
+      <p:sp>
+        <p:nvSpPr>
+          <p:cNvPr id="10" name="Text 8"/>
+          <p:cNvSpPr/>
+          <p:nvPr/>
+        </p:nvSpPr>
+        <p:spPr>
+          <a:xfrm>
+            <a:off x="3474720" y="2468880"/>
+            <a:ext cx="2194560" cy="1371600"/>
+          </a:xfrm>
+          <a:prstGeom prst="rect">
+            <a:avLst/>
+          </a:prstGeom>
+          <a:noFill/>
+          <a:ln/>
+        </p:spPr>
+        <p:txBody>
+          <a:bodyPr wrap="square" lIns="0" tIns="0" rIns="0" bIns="0" rtlCol="0" anchor="t"/>
           <a:lstStyle/>
           <a:p>
             <a:pPr indent="0" marL="0">
               <a:buNone/>
             </a:pPr>
             <a:r>
-              <a:rPr lang="en-US" sz="1200" dirty="0">
+              <a:rPr lang="en-US" sz="1150" dirty="0">
                 <a:solidFill>
                   <a:srgbClr val="6B7280"/>
                 </a:solidFill>
@@ -4797,26 +5233,26 @@
                 <a:ea typeface="Calibri" pitchFamily="34" charset="-122"/>
                 <a:cs typeface="Calibri" pitchFamily="34" charset="-120"/>
               </a:rPr>
-              <a:t>економії щомісяця (≈ 340 тис/рік)</a:t>
-            </a:r>
-            <a:endParaRPr lang="en-US" sz="1200" dirty="0"/>
-          </a:p>
-        </p:txBody>
-      </p:sp>
-      <p:sp>
-        <p:nvSpPr>
-          <p:cNvPr id="10" name="Shape 7"/>
-          <p:cNvSpPr/>
-          <p:nvPr/>
-        </p:nvSpPr>
-        <p:spPr>
-          <a:xfrm>
-            <a:off x="4846320" y="3163824"/>
-            <a:ext cx="3840480" cy="841248"/>
+              <a:t>Знаходить дубль підписки після SUBSCRIPTION_CREATE_RETRY. Окремо: скасувати дубль і подати запит на повернення (pending_review, гроші не рухаються без людини).</a:t>
+            </a:r>
+            <a:endParaRPr lang="en-US" sz="1150" dirty="0"/>
+          </a:p>
+        </p:txBody>
+      </p:sp>
+      <p:sp>
+        <p:nvSpPr>
+          <p:cNvPr id="11" name="Shape 9"/>
+          <p:cNvSpPr/>
+          <p:nvPr/>
+        </p:nvSpPr>
+        <p:spPr>
+          <a:xfrm>
+            <a:off x="6035040" y="1188720"/>
+            <a:ext cx="2606040" cy="2697480"/>
           </a:xfrm>
           <a:prstGeom prst="roundRect">
             <a:avLst>
-              <a:gd name="adj" fmla="val 13043"/>
+              <a:gd name="adj" fmla="val 4211"/>
             </a:avLst>
           </a:prstGeom>
           <a:solidFill>
@@ -4834,69 +5270,89 @@
       </p:sp>
       <p:sp>
         <p:nvSpPr>
-          <p:cNvPr id="11" name="Text 8"/>
-          <p:cNvSpPr/>
-          <p:nvPr/>
-        </p:nvSpPr>
-        <p:spPr>
-          <a:xfrm>
-            <a:off x="5029200" y="3236976"/>
-            <a:ext cx="3566160" cy="438912"/>
-          </a:xfrm>
-          <a:prstGeom prst="rect">
-            <a:avLst/>
-          </a:prstGeom>
-          <a:noFill/>
-          <a:ln/>
-        </p:spPr>
-        <p:txBody>
-          <a:bodyPr wrap="square" lIns="0" tIns="0" rIns="0" bIns="0" rtlCol="0" anchor="ctr"/>
+          <p:cNvPr id="12" name="Shape 10"/>
+          <p:cNvSpPr/>
+          <p:nvPr/>
+        </p:nvSpPr>
+        <p:spPr>
+          <a:xfrm>
+            <a:off x="6263640" y="1325880"/>
+            <a:ext cx="411480" cy="411480"/>
+          </a:xfrm>
+          <a:prstGeom prst="ellipse">
+            <a:avLst/>
+          </a:prstGeom>
+          <a:solidFill>
+            <a:srgbClr val="F2A541"/>
+          </a:solidFill>
+          <a:ln/>
+        </p:spPr>
+      </p:sp>
+      <p:sp>
+        <p:nvSpPr>
+          <p:cNvPr id="13" name="Text 11"/>
+          <p:cNvSpPr/>
+          <p:nvPr/>
+        </p:nvSpPr>
+        <p:spPr>
+          <a:xfrm>
+            <a:off x="6263640" y="1810512"/>
+            <a:ext cx="2194560" cy="640080"/>
+          </a:xfrm>
+          <a:prstGeom prst="rect">
+            <a:avLst/>
+          </a:prstGeom>
+          <a:noFill/>
+          <a:ln/>
+        </p:spPr>
+        <p:txBody>
+          <a:bodyPr wrap="square" lIns="0" tIns="0" rIns="0" bIns="0" rtlCol="0" anchor="t"/>
           <a:lstStyle/>
           <a:p>
             <a:pPr indent="0" marL="0">
               <a:buNone/>
             </a:pPr>
             <a:r>
-              <a:rPr lang="en-US" sz="2400" b="1" dirty="0">
-                <a:solidFill>
-                  <a:srgbClr val="2A9D8F"/>
-                </a:solidFill>
-                <a:latin typeface="Cambria" pitchFamily="34" charset="0"/>
-                <a:ea typeface="Cambria" pitchFamily="34" charset="-122"/>
-                <a:cs typeface="Cambria" pitchFamily="34" charset="-120"/>
-              </a:rPr>
-              <a:t>5 с</a:t>
-            </a:r>
-            <a:endParaRPr lang="en-US" sz="2400" dirty="0"/>
-          </a:p>
-        </p:txBody>
-      </p:sp>
-      <p:sp>
-        <p:nvSpPr>
-          <p:cNvPr id="12" name="Text 9"/>
-          <p:cNvSpPr/>
-          <p:nvPr/>
-        </p:nvSpPr>
-        <p:spPr>
-          <a:xfrm>
-            <a:off x="5029200" y="3666744"/>
-            <a:ext cx="3566160" cy="274320"/>
-          </a:xfrm>
-          <a:prstGeom prst="rect">
-            <a:avLst/>
-          </a:prstGeom>
-          <a:noFill/>
-          <a:ln/>
-        </p:spPr>
-        <p:txBody>
-          <a:bodyPr wrap="square" lIns="0" tIns="0" rIns="0" bIns="0" rtlCol="0" anchor="ctr"/>
+              <a:rPr lang="en-US" sz="1500" b="1" dirty="0">
+                <a:solidFill>
+                  <a:srgbClr val="1B2440"/>
+                </a:solidFill>
+                <a:latin typeface="Calibri" pitchFamily="34" charset="0"/>
+                <a:ea typeface="Calibri" pitchFamily="34" charset="-122"/>
+                <a:cs typeface="Calibri" pitchFamily="34" charset="-120"/>
+              </a:rPr>
+              <a:t>Створи промокод -10% до 10 листопада</a:t>
+            </a:r>
+            <a:endParaRPr lang="en-US" sz="1500" dirty="0"/>
+          </a:p>
+        </p:txBody>
+      </p:sp>
+      <p:sp>
+        <p:nvSpPr>
+          <p:cNvPr id="14" name="Text 12"/>
+          <p:cNvSpPr/>
+          <p:nvPr/>
+        </p:nvSpPr>
+        <p:spPr>
+          <a:xfrm>
+            <a:off x="6263640" y="2468880"/>
+            <a:ext cx="2194560" cy="1371600"/>
+          </a:xfrm>
+          <a:prstGeom prst="rect">
+            <a:avLst/>
+          </a:prstGeom>
+          <a:noFill/>
+          <a:ln/>
+        </p:spPr>
+        <p:txBody>
+          <a:bodyPr wrap="square" lIns="0" tIns="0" rIns="0" bIns="0" rtlCol="0" anchor="t"/>
           <a:lstStyle/>
           <a:p>
             <a:pPr indent="0" marL="0">
               <a:buNone/>
             </a:pPr>
             <a:r>
-              <a:rPr lang="en-US" sz="1200" dirty="0">
+              <a:rPr lang="en-US" sz="1150" dirty="0">
                 <a:solidFill>
                   <a:srgbClr val="6B7280"/>
                 </a:solidFill>
@@ -4904,22 +5360,47 @@
                 <a:ea typeface="Calibri" pitchFamily="34" charset="-122"/>
                 <a:cs typeface="Calibri" pitchFamily="34" charset="-120"/>
               </a:rPr>
-              <a:t>до першої відповіді з доказами</a:t>
-            </a:r>
-            <a:endParaRPr lang="en-US" sz="1200" dirty="0"/>
-          </a:p>
-        </p:txBody>
-      </p:sp>
-      <p:sp>
-        <p:nvSpPr>
-          <p:cNvPr id="13" name="Text 10"/>
-          <p:cNvSpPr/>
-          <p:nvPr/>
-        </p:nvSpPr>
-        <p:spPr>
-          <a:xfrm>
-            <a:off x="457200" y="4434840"/>
-            <a:ext cx="8229600" cy="365760"/>
+              <a:t>Уточнює ліміт використань, показує превʼю, створює промокод після підтвердження.</a:t>
+            </a:r>
+            <a:endParaRPr lang="en-US" sz="1150" dirty="0"/>
+          </a:p>
+        </p:txBody>
+      </p:sp>
+      <p:sp>
+        <p:nvSpPr>
+          <p:cNvPr id="15" name="Shape 13"/>
+          <p:cNvSpPr/>
+          <p:nvPr/>
+        </p:nvSpPr>
+        <p:spPr>
+          <a:xfrm>
+            <a:off x="457200" y="4023360"/>
+            <a:ext cx="8229600" cy="685800"/>
+          </a:xfrm>
+          <a:prstGeom prst="rect">
+            <a:avLst/>
+          </a:prstGeom>
+          <a:solidFill>
+            <a:srgbClr val="FFF4E0"/>
+          </a:solidFill>
+          <a:ln w="19050">
+            <a:solidFill>
+              <a:srgbClr val="F2A541"/>
+            </a:solidFill>
+            <a:prstDash val="dash"/>
+          </a:ln>
+        </p:spPr>
+      </p:sp>
+      <p:sp>
+        <p:nvSpPr>
+          <p:cNvPr id="16" name="Text 14"/>
+          <p:cNvSpPr/>
+          <p:nvPr/>
+        </p:nvSpPr>
+        <p:spPr>
+          <a:xfrm>
+            <a:off x="640080" y="4023360"/>
+            <a:ext cx="7863840" cy="685800"/>
           </a:xfrm>
           <a:prstGeom prst="rect">
             <a:avLst/>
@@ -4935,17 +5416,17 @@
               <a:buNone/>
             </a:pPr>
             <a:r>
-              <a:rPr lang="en-US" sz="1000" dirty="0">
-                <a:solidFill>
-                  <a:srgbClr val="6B7280"/>
-                </a:solidFill>
-                <a:latin typeface="Calibri" pitchFamily="34" charset="0"/>
-                <a:ea typeface="Calibri" pitchFamily="34" charset="-122"/>
-                <a:cs typeface="Calibri" pitchFamily="34" charset="-120"/>
-              </a:rPr>
-              <a:t>Модель: 1 000 тікетів/міс × 12 хв; 75% автоматизовано; 190 грн/год саппорту. Припущення, крім 75% (наш корпус) і 5 с (замір).</a:t>
-            </a:r>
-            <a:endParaRPr lang="en-US" sz="1000" dirty="0"/>
+              <a:rPr lang="en-US" sz="1600" b="1" dirty="0">
+                <a:solidFill>
+                  <a:srgbClr val="1B2440"/>
+                </a:solidFill>
+                <a:latin typeface="Calibri" pitchFamily="34" charset="0"/>
+                <a:ea typeface="Calibri" pitchFamily="34" charset="-122"/>
+                <a:cs typeface="Calibri" pitchFamily="34" charset="-120"/>
+              </a:rPr>
+              <a:t>ВІДЕО: &lt;посилання&gt;  (запис робочого сценарію, вставити сюди)</a:t>
+            </a:r>
+            <a:endParaRPr lang="en-US" sz="1600" dirty="0"/>
           </a:p>
         </p:txBody>
       </p:sp>
@@ -5014,7 +5495,7 @@
                 <a:ea typeface="Cambria" pitchFamily="34" charset="-122"/>
                 <a:cs typeface="Cambria" pitchFamily="34" charset="-120"/>
               </a:rPr>
-              <a:t>Довіра: виміряно сьогодні</a:t>
+              <a:t>Безпека: модель пропонує, код вирішує</a:t>
             </a:r>
             <a:endParaRPr lang="en-US" sz="3000" dirty="0"/>
           </a:p>
@@ -5486,6 +5967,27 @@
                 <a:cs typeface="Calibri" pitchFamily="34" charset="-120"/>
               </a:rPr>
               <a:t>Текст клієнта це дані, не інструкції: спроби атаки (TCK-1011) і отруєння бази (TCK-1012) не змінюють поведінку</a:t>
+            </a:r>
+            <a:endParaRPr lang="en-US" sz="1300" dirty="0"/>
+          </a:p>
+          <a:p>
+            <a:pPr marL="342900" indent="-342900">
+              <a:spcAft>
+                <a:spcPts val="600"/>
+              </a:spcAft>
+              <a:buSzPct val="100000"/>
+              <a:buChar char="•"/>
+            </a:pPr>
+            <a:r>
+              <a:rPr lang="en-US" sz="1300" dirty="0">
+                <a:solidFill>
+                  <a:srgbClr val="1B2440"/>
+                </a:solidFill>
+                <a:latin typeface="Calibri" pitchFamily="34" charset="0"/>
+                <a:ea typeface="Calibri" pitchFamily="34" charset="-122"/>
+                <a:cs typeface="Calibri" pitchFamily="34" charset="-120"/>
+              </a:rPr>
+              <a:t>Знання з тікетів спершу pending_review і без перевірки не потрапляють у відповіді</a:t>
             </a:r>
             <a:endParaRPr lang="en-US" sz="1300" dirty="0"/>
           </a:p>
@@ -5523,6 +6025,453 @@
 <file path=ppt/slides/slide8.xml><?xml version="1.0" encoding="utf-8"?>
 <p:sld xmlns:a="http://schemas.openxmlformats.org/drawingml/2006/main" xmlns:r="http://schemas.openxmlformats.org/officeDocument/2006/relationships" xmlns:p="http://schemas.openxmlformats.org/presentationml/2006/main">
   <p:cSld name="Slide 8">
+    <p:bg>
+      <p:bgPr>
+        <a:solidFill>
+          <a:srgbClr val="F4F6FA"/>
+        </a:solidFill>
+      </p:bgPr>
+    </p:bg>
+    <p:spTree>
+      <p:nvGrpSpPr>
+        <p:cNvPr id="1" name=""/>
+        <p:cNvGrpSpPr/>
+        <p:nvPr/>
+      </p:nvGrpSpPr>
+      <p:grpSpPr>
+        <a:xfrm>
+          <a:off x="0" y="0"/>
+          <a:ext cx="0" cy="0"/>
+          <a:chOff x="0" y="0"/>
+          <a:chExt cx="0" cy="0"/>
+        </a:xfrm>
+      </p:grpSpPr>
+      <p:sp>
+        <p:nvSpPr>
+          <p:cNvPr id="2" name="Text 0"/>
+          <p:cNvSpPr/>
+          <p:nvPr/>
+        </p:nvSpPr>
+        <p:spPr>
+          <a:xfrm>
+            <a:off x="457200" y="320040"/>
+            <a:ext cx="8229600" cy="640080"/>
+          </a:xfrm>
+          <a:prstGeom prst="rect">
+            <a:avLst/>
+          </a:prstGeom>
+          <a:noFill/>
+          <a:ln/>
+        </p:spPr>
+        <p:txBody>
+          <a:bodyPr wrap="square" lIns="0" tIns="0" rIns="0" bIns="0" rtlCol="0" anchor="ctr"/>
+          <a:lstStyle/>
+          <a:p>
+            <a:pPr indent="0" marL="0">
+              <a:buNone/>
+            </a:pPr>
+            <a:r>
+              <a:rPr lang="en-US" sz="3000" b="1" dirty="0">
+                <a:solidFill>
+                  <a:srgbClr val="1B2440"/>
+                </a:solidFill>
+                <a:latin typeface="Cambria" pitchFamily="34" charset="0"/>
+                <a:ea typeface="Cambria" pitchFamily="34" charset="-122"/>
+                <a:cs typeface="Cambria" pitchFamily="34" charset="-120"/>
+              </a:rPr>
+              <a:t>Цінність для компанії-розробника</a:t>
+            </a:r>
+            <a:endParaRPr lang="en-US" sz="3000" dirty="0"/>
+          </a:p>
+        </p:txBody>
+      </p:sp>
+      <p:graphicFrame>
+        <p:nvGraphicFramePr>
+          <p:cNvPr id="3" name="Chart 0" descr=""/>
+          <p:cNvGraphicFramePr/>
+          <p:nvPr/>
+        </p:nvGraphicFramePr>
+        <p:xfrm>
+          <a:off x="365760" y="1143000"/>
+          <a:ext cx="4206240" cy="3108960"/>
+        </p:xfrm>
+        <a:graphic xmlns:a="http://schemas.openxmlformats.org/drawingml/2006/main">
+          <a:graphicData uri="http://schemas.openxmlformats.org/drawingml/2006/chart">
+            <c:chart xmlns:c="http://schemas.openxmlformats.org/drawingml/2006/chart" r:id="rId1"/>
+          </a:graphicData>
+        </a:graphic>
+      </p:graphicFrame>
+      <p:sp>
+        <p:nvSpPr>
+          <p:cNvPr id="4" name="Shape 1"/>
+          <p:cNvSpPr/>
+          <p:nvPr/>
+        </p:nvSpPr>
+        <p:spPr>
+          <a:xfrm>
+            <a:off x="4846320" y="1188720"/>
+            <a:ext cx="3840480" cy="841248"/>
+          </a:xfrm>
+          <a:prstGeom prst="roundRect">
+            <a:avLst>
+              <a:gd name="adj" fmla="val 13043"/>
+            </a:avLst>
+          </a:prstGeom>
+          <a:solidFill>
+            <a:srgbClr val="FFFFFF"/>
+          </a:solidFill>
+          <a:ln/>
+          <a:effectLst>
+            <a:outerShdw sx="100000" sy="100000" kx="0" ky="0" algn="bl" rotWithShape="0" blurRad="76200" dist="25400" dir="5400000">
+              <a:srgbClr val="000000">
+                <a:alpha val="12000"/>
+              </a:srgbClr>
+            </a:outerShdw>
+          </a:effectLst>
+        </p:spPr>
+      </p:sp>
+      <p:sp>
+        <p:nvSpPr>
+          <p:cNvPr id="5" name="Text 2"/>
+          <p:cNvSpPr/>
+          <p:nvPr/>
+        </p:nvSpPr>
+        <p:spPr>
+          <a:xfrm>
+            <a:off x="5029200" y="1261872"/>
+            <a:ext cx="3566160" cy="438912"/>
+          </a:xfrm>
+          <a:prstGeom prst="rect">
+            <a:avLst/>
+          </a:prstGeom>
+          <a:noFill/>
+          <a:ln/>
+        </p:spPr>
+        <p:txBody>
+          <a:bodyPr wrap="square" lIns="0" tIns="0" rIns="0" bIns="0" rtlCol="0" anchor="ctr"/>
+          <a:lstStyle/>
+          <a:p>
+            <a:pPr indent="0" marL="0">
+              <a:buNone/>
+            </a:pPr>
+            <a:r>
+              <a:rPr lang="en-US" sz="2400" b="1" dirty="0">
+                <a:solidFill>
+                  <a:srgbClr val="1B2440"/>
+                </a:solidFill>
+                <a:latin typeface="Cambria" pitchFamily="34" charset="0"/>
+                <a:ea typeface="Cambria" pitchFamily="34" charset="-122"/>
+                <a:cs typeface="Cambria" pitchFamily="34" charset="-120"/>
+              </a:rPr>
+              <a:t>−150 год</a:t>
+            </a:r>
+            <a:endParaRPr lang="en-US" sz="2400" dirty="0"/>
+          </a:p>
+        </p:txBody>
+      </p:sp>
+      <p:sp>
+        <p:nvSpPr>
+          <p:cNvPr id="6" name="Text 3"/>
+          <p:cNvSpPr/>
+          <p:nvPr/>
+        </p:nvSpPr>
+        <p:spPr>
+          <a:xfrm>
+            <a:off x="5029200" y="1691640"/>
+            <a:ext cx="3566160" cy="274320"/>
+          </a:xfrm>
+          <a:prstGeom prst="rect">
+            <a:avLst/>
+          </a:prstGeom>
+          <a:noFill/>
+          <a:ln/>
+        </p:spPr>
+        <p:txBody>
+          <a:bodyPr wrap="square" lIns="0" tIns="0" rIns="0" bIns="0" rtlCol="0" anchor="ctr"/>
+          <a:lstStyle/>
+          <a:p>
+            <a:pPr indent="0" marL="0">
+              <a:buNone/>
+            </a:pPr>
+            <a:r>
+              <a:rPr lang="en-US" sz="1200" dirty="0">
+                <a:solidFill>
+                  <a:srgbClr val="6B7280"/>
+                </a:solidFill>
+                <a:latin typeface="Calibri" pitchFamily="34" charset="0"/>
+                <a:ea typeface="Calibri" pitchFamily="34" charset="-122"/>
+                <a:cs typeface="Calibri" pitchFamily="34" charset="-120"/>
+              </a:rPr>
+              <a:t>на місяць ≈ 0,9 FTE</a:t>
+            </a:r>
+            <a:endParaRPr lang="en-US" sz="1200" dirty="0"/>
+          </a:p>
+        </p:txBody>
+      </p:sp>
+      <p:sp>
+        <p:nvSpPr>
+          <p:cNvPr id="7" name="Shape 4"/>
+          <p:cNvSpPr/>
+          <p:nvPr/>
+        </p:nvSpPr>
+        <p:spPr>
+          <a:xfrm>
+            <a:off x="4846320" y="2176272"/>
+            <a:ext cx="3840480" cy="841248"/>
+          </a:xfrm>
+          <a:prstGeom prst="roundRect">
+            <a:avLst>
+              <a:gd name="adj" fmla="val 13043"/>
+            </a:avLst>
+          </a:prstGeom>
+          <a:solidFill>
+            <a:srgbClr val="FFFFFF"/>
+          </a:solidFill>
+          <a:ln/>
+          <a:effectLst>
+            <a:outerShdw sx="100000" sy="100000" kx="0" ky="0" algn="bl" rotWithShape="0" blurRad="76200" dist="25400" dir="5400000">
+              <a:srgbClr val="000000">
+                <a:alpha val="12000"/>
+              </a:srgbClr>
+            </a:outerShdw>
+          </a:effectLst>
+        </p:spPr>
+      </p:sp>
+      <p:sp>
+        <p:nvSpPr>
+          <p:cNvPr id="8" name="Text 5"/>
+          <p:cNvSpPr/>
+          <p:nvPr/>
+        </p:nvSpPr>
+        <p:spPr>
+          <a:xfrm>
+            <a:off x="5029200" y="2249424"/>
+            <a:ext cx="3566160" cy="438912"/>
+          </a:xfrm>
+          <a:prstGeom prst="rect">
+            <a:avLst/>
+          </a:prstGeom>
+          <a:noFill/>
+          <a:ln/>
+        </p:spPr>
+        <p:txBody>
+          <a:bodyPr wrap="square" lIns="0" tIns="0" rIns="0" bIns="0" rtlCol="0" anchor="ctr"/>
+          <a:lstStyle/>
+          <a:p>
+            <a:pPr indent="0" marL="0">
+              <a:buNone/>
+            </a:pPr>
+            <a:r>
+              <a:rPr lang="en-US" sz="2400" b="1" dirty="0">
+                <a:solidFill>
+                  <a:srgbClr val="1B2440"/>
+                </a:solidFill>
+                <a:latin typeface="Cambria" pitchFamily="34" charset="0"/>
+                <a:ea typeface="Cambria" pitchFamily="34" charset="-122"/>
+                <a:cs typeface="Cambria" pitchFamily="34" charset="-120"/>
+              </a:rPr>
+              <a:t>≈ 28 500 грн</a:t>
+            </a:r>
+            <a:endParaRPr lang="en-US" sz="2400" dirty="0"/>
+          </a:p>
+        </p:txBody>
+      </p:sp>
+      <p:sp>
+        <p:nvSpPr>
+          <p:cNvPr id="9" name="Text 6"/>
+          <p:cNvSpPr/>
+          <p:nvPr/>
+        </p:nvSpPr>
+        <p:spPr>
+          <a:xfrm>
+            <a:off x="5029200" y="2679192"/>
+            <a:ext cx="3566160" cy="274320"/>
+          </a:xfrm>
+          <a:prstGeom prst="rect">
+            <a:avLst/>
+          </a:prstGeom>
+          <a:noFill/>
+          <a:ln/>
+        </p:spPr>
+        <p:txBody>
+          <a:bodyPr wrap="square" lIns="0" tIns="0" rIns="0" bIns="0" rtlCol="0" anchor="ctr"/>
+          <a:lstStyle/>
+          <a:p>
+            <a:pPr indent="0" marL="0">
+              <a:buNone/>
+            </a:pPr>
+            <a:r>
+              <a:rPr lang="en-US" sz="1200" dirty="0">
+                <a:solidFill>
+                  <a:srgbClr val="6B7280"/>
+                </a:solidFill>
+                <a:latin typeface="Calibri" pitchFamily="34" charset="0"/>
+                <a:ea typeface="Calibri" pitchFamily="34" charset="-122"/>
+                <a:cs typeface="Calibri" pitchFamily="34" charset="-120"/>
+              </a:rPr>
+              <a:t>економії щомісяця (≈ 340 тис/рік)</a:t>
+            </a:r>
+            <a:endParaRPr lang="en-US" sz="1200" dirty="0"/>
+          </a:p>
+        </p:txBody>
+      </p:sp>
+      <p:sp>
+        <p:nvSpPr>
+          <p:cNvPr id="10" name="Shape 7"/>
+          <p:cNvSpPr/>
+          <p:nvPr/>
+        </p:nvSpPr>
+        <p:spPr>
+          <a:xfrm>
+            <a:off x="4846320" y="3163824"/>
+            <a:ext cx="3840480" cy="841248"/>
+          </a:xfrm>
+          <a:prstGeom prst="roundRect">
+            <a:avLst>
+              <a:gd name="adj" fmla="val 13043"/>
+            </a:avLst>
+          </a:prstGeom>
+          <a:solidFill>
+            <a:srgbClr val="FFFFFF"/>
+          </a:solidFill>
+          <a:ln/>
+          <a:effectLst>
+            <a:outerShdw sx="100000" sy="100000" kx="0" ky="0" algn="bl" rotWithShape="0" blurRad="76200" dist="25400" dir="5400000">
+              <a:srgbClr val="000000">
+                <a:alpha val="12000"/>
+              </a:srgbClr>
+            </a:outerShdw>
+          </a:effectLst>
+        </p:spPr>
+      </p:sp>
+      <p:sp>
+        <p:nvSpPr>
+          <p:cNvPr id="11" name="Text 8"/>
+          <p:cNvSpPr/>
+          <p:nvPr/>
+        </p:nvSpPr>
+        <p:spPr>
+          <a:xfrm>
+            <a:off x="5029200" y="3236976"/>
+            <a:ext cx="3566160" cy="438912"/>
+          </a:xfrm>
+          <a:prstGeom prst="rect">
+            <a:avLst/>
+          </a:prstGeom>
+          <a:noFill/>
+          <a:ln/>
+        </p:spPr>
+        <p:txBody>
+          <a:bodyPr wrap="square" lIns="0" tIns="0" rIns="0" bIns="0" rtlCol="0" anchor="ctr"/>
+          <a:lstStyle/>
+          <a:p>
+            <a:pPr indent="0" marL="0">
+              <a:buNone/>
+            </a:pPr>
+            <a:r>
+              <a:rPr lang="en-US" sz="1800" b="1" dirty="0">
+                <a:solidFill>
+                  <a:srgbClr val="2A9D8F"/>
+                </a:solidFill>
+                <a:latin typeface="Cambria" pitchFamily="34" charset="0"/>
+                <a:ea typeface="Cambria" pitchFamily="34" charset="-122"/>
+                <a:cs typeface="Cambria" pitchFamily="34" charset="-120"/>
+              </a:rPr>
+              <a:t>«Зекономлено N хв»</a:t>
+            </a:r>
+            <a:endParaRPr lang="en-US" sz="1800" dirty="0"/>
+          </a:p>
+        </p:txBody>
+      </p:sp>
+      <p:sp>
+        <p:nvSpPr>
+          <p:cNvPr id="12" name="Text 9"/>
+          <p:cNvSpPr/>
+          <p:nvPr/>
+        </p:nvSpPr>
+        <p:spPr>
+          <a:xfrm>
+            <a:off x="5029200" y="3666744"/>
+            <a:ext cx="3566160" cy="274320"/>
+          </a:xfrm>
+          <a:prstGeom prst="rect">
+            <a:avLst/>
+          </a:prstGeom>
+          <a:noFill/>
+          <a:ln/>
+        </p:spPr>
+        <p:txBody>
+          <a:bodyPr wrap="square" lIns="0" tIns="0" rIns="0" bIns="0" rtlCol="0" anchor="ctr"/>
+          <a:lstStyle/>
+          <a:p>
+            <a:pPr indent="0" marL="0">
+              <a:buNone/>
+            </a:pPr>
+            <a:r>
+              <a:rPr lang="en-US" sz="1200" dirty="0">
+                <a:solidFill>
+                  <a:srgbClr val="6B7280"/>
+                </a:solidFill>
+                <a:latin typeface="Calibri" pitchFamily="34" charset="0"/>
+                <a:ea typeface="Calibri" pitchFamily="34" charset="-122"/>
+                <a:cs typeface="Calibri" pitchFamily="34" charset="-120"/>
+              </a:rPr>
+              <a:t>лічильник у застосунку після кожного звернення</a:t>
+            </a:r>
+            <a:endParaRPr lang="en-US" sz="1200" dirty="0"/>
+          </a:p>
+        </p:txBody>
+      </p:sp>
+      <p:sp>
+        <p:nvSpPr>
+          <p:cNvPr id="13" name="Text 10"/>
+          <p:cNvSpPr/>
+          <p:nvPr/>
+        </p:nvSpPr>
+        <p:spPr>
+          <a:xfrm>
+            <a:off x="457200" y="4434840"/>
+            <a:ext cx="8229600" cy="365760"/>
+          </a:xfrm>
+          <a:prstGeom prst="rect">
+            <a:avLst/>
+          </a:prstGeom>
+          <a:noFill/>
+          <a:ln/>
+        </p:spPr>
+        <p:txBody>
+          <a:bodyPr wrap="square" lIns="0" tIns="0" rIns="0" bIns="0" rtlCol="0" anchor="ctr"/>
+          <a:lstStyle/>
+          <a:p>
+            <a:pPr indent="0" marL="0">
+              <a:buNone/>
+            </a:pPr>
+            <a:r>
+              <a:rPr lang="en-US" sz="1000" dirty="0">
+                <a:solidFill>
+                  <a:srgbClr val="6B7280"/>
+                </a:solidFill>
+                <a:latin typeface="Calibri" pitchFamily="34" charset="0"/>
+                <a:ea typeface="Calibri" pitchFamily="34" charset="-122"/>
+                <a:cs typeface="Calibri" pitchFamily="34" charset="-120"/>
+              </a:rPr>
+              <a:t>Модель: 1 000 тікетів/міс × 12 хв; 75% автоматизовано; 190 грн/год саппорту. Припущення, крім 75% (наш корпус) і 5 с (замір).</a:t>
+            </a:r>
+            <a:endParaRPr lang="en-US" sz="1000" dirty="0"/>
+          </a:p>
+        </p:txBody>
+      </p:sp>
+    </p:spTree>
+  </p:cSld>
+  <p:clrMapOvr>
+    <a:masterClrMapping/>
+  </p:clrMapOvr>
+</p:sld>
+</file>
+
+<file path=ppt/slides/slide9.xml><?xml version="1.0" encoding="utf-8"?>
+<p:sld xmlns:a="http://schemas.openxmlformats.org/drawingml/2006/main" xmlns:r="http://schemas.openxmlformats.org/officeDocument/2006/relationships" xmlns:p="http://schemas.openxmlformats.org/presentationml/2006/main">
+  <p:cSld name="Slide 9">
     <p:bg>
       <p:bgPr>
         <a:solidFill>
@@ -5577,7 +6526,7 @@
                 <a:ea typeface="Cambria" pitchFamily="34" charset="-122"/>
                 <a:cs typeface="Cambria" pitchFamily="34" charset="-120"/>
               </a:rPr>
-              <a:t>Наступний крок</a:t>
+              <a:t>Дорожня карта</a:t>
             </a:r>
             <a:endParaRPr lang="en-US" sz="3000" dirty="0"/>
           </a:p>
@@ -5591,7 +6540,7 @@
         </p:nvSpPr>
         <p:spPr>
           <a:xfrm>
-            <a:off x="457200" y="1280160"/>
+            <a:off x="457200" y="1188720"/>
             <a:ext cx="457200" cy="457200"/>
           </a:xfrm>
           <a:prstGeom prst="ellipse">
@@ -5611,7 +6560,7 @@
         </p:nvSpPr>
         <p:spPr>
           <a:xfrm>
-            <a:off x="457200" y="1280160"/>
+            <a:off x="457200" y="1188720"/>
             <a:ext cx="457200" cy="457200"/>
           </a:xfrm>
           <a:prstGeom prst="rect">
@@ -5650,7 +6599,7 @@
         </p:nvSpPr>
         <p:spPr>
           <a:xfrm>
-            <a:off x="1097280" y="1188720"/>
+            <a:off x="1097280" y="1097280"/>
             <a:ext cx="7315200" cy="365760"/>
           </a:xfrm>
           <a:prstGeom prst="rect">
@@ -5689,7 +6638,7 @@
         </p:nvSpPr>
         <p:spPr>
           <a:xfrm>
-            <a:off x="1097280" y="1572768"/>
+            <a:off x="1097280" y="1481328"/>
             <a:ext cx="7315200" cy="365760"/>
           </a:xfrm>
           <a:prstGeom prst="rect">
@@ -5728,7 +6677,7 @@
         </p:nvSpPr>
         <p:spPr>
           <a:xfrm>
-            <a:off x="457200" y="2331720"/>
+            <a:off x="457200" y="1993392"/>
             <a:ext cx="457200" cy="457200"/>
           </a:xfrm>
           <a:prstGeom prst="ellipse">
@@ -5748,7 +6697,7 @@
         </p:nvSpPr>
         <p:spPr>
           <a:xfrm>
-            <a:off x="457200" y="2331720"/>
+            <a:off x="457200" y="1993392"/>
             <a:ext cx="457200" cy="457200"/>
           </a:xfrm>
           <a:prstGeom prst="rect">
@@ -5787,7 +6736,7 @@
         </p:nvSpPr>
         <p:spPr>
           <a:xfrm>
-            <a:off x="1097280" y="2240280"/>
+            <a:off x="1097280" y="1901952"/>
             <a:ext cx="7315200" cy="365760"/>
           </a:xfrm>
           <a:prstGeom prst="rect">
@@ -5826,7 +6775,7 @@
         </p:nvSpPr>
         <p:spPr>
           <a:xfrm>
-            <a:off x="1097280" y="2624328"/>
+            <a:off x="1097280" y="2286000"/>
             <a:ext cx="7315200" cy="365760"/>
           </a:xfrm>
           <a:prstGeom prst="rect">
@@ -5865,7 +6814,7 @@
         </p:nvSpPr>
         <p:spPr>
           <a:xfrm>
-            <a:off x="457200" y="3383280"/>
+            <a:off x="457200" y="2798064"/>
             <a:ext cx="457200" cy="457200"/>
           </a:xfrm>
           <a:prstGeom prst="ellipse">
@@ -5885,7 +6834,7 @@
         </p:nvSpPr>
         <p:spPr>
           <a:xfrm>
-            <a:off x="457200" y="3383280"/>
+            <a:off x="457200" y="2798064"/>
             <a:ext cx="457200" cy="457200"/>
           </a:xfrm>
           <a:prstGeom prst="rect">
@@ -5924,7 +6873,7 @@
         </p:nvSpPr>
         <p:spPr>
           <a:xfrm>
-            <a:off x="1097280" y="3291840"/>
+            <a:off x="1097280" y="2706624"/>
             <a:ext cx="7315200" cy="365760"/>
           </a:xfrm>
           <a:prstGeom prst="rect">
@@ -5963,7 +6912,7 @@
         </p:nvSpPr>
         <p:spPr>
           <a:xfrm>
-            <a:off x="1097280" y="3675888"/>
+            <a:off x="1097280" y="3090672"/>
             <a:ext cx="7315200" cy="365760"/>
           </a:xfrm>
           <a:prstGeom prst="rect">
@@ -5996,14 +6945,73 @@
       </p:sp>
       <p:sp>
         <p:nvSpPr>
-          <p:cNvPr id="15" name="Text 13"/>
-          <p:cNvSpPr/>
-          <p:nvPr/>
-        </p:nvSpPr>
-        <p:spPr>
-          <a:xfrm>
-            <a:off x="457200" y="4343400"/>
-            <a:ext cx="8229600" cy="411480"/>
+          <p:cNvPr id="15" name="Shape 13"/>
+          <p:cNvSpPr/>
+          <p:nvPr/>
+        </p:nvSpPr>
+        <p:spPr>
+          <a:xfrm>
+            <a:off x="457200" y="3602736"/>
+            <a:ext cx="457200" cy="457200"/>
+          </a:xfrm>
+          <a:prstGeom prst="ellipse">
+            <a:avLst/>
+          </a:prstGeom>
+          <a:solidFill>
+            <a:srgbClr val="F2A541"/>
+          </a:solidFill>
+          <a:ln/>
+        </p:spPr>
+      </p:sp>
+      <p:sp>
+        <p:nvSpPr>
+          <p:cNvPr id="16" name="Text 14"/>
+          <p:cNvSpPr/>
+          <p:nvPr/>
+        </p:nvSpPr>
+        <p:spPr>
+          <a:xfrm>
+            <a:off x="457200" y="3602736"/>
+            <a:ext cx="457200" cy="457200"/>
+          </a:xfrm>
+          <a:prstGeom prst="rect">
+            <a:avLst/>
+          </a:prstGeom>
+          <a:noFill/>
+          <a:ln/>
+        </p:spPr>
+        <p:txBody>
+          <a:bodyPr wrap="square" lIns="0" tIns="0" rIns="0" bIns="0" rtlCol="0" anchor="ctr"/>
+          <a:lstStyle/>
+          <a:p>
+            <a:pPr algn="ctr" indent="0" marL="0">
+              <a:buNone/>
+            </a:pPr>
+            <a:r>
+              <a:rPr lang="en-US" sz="1600" b="1" dirty="0">
+                <a:solidFill>
+                  <a:srgbClr val="1B2440"/>
+                </a:solidFill>
+                <a:latin typeface="Calibri" pitchFamily="34" charset="0"/>
+                <a:ea typeface="Calibri" pitchFamily="34" charset="-122"/>
+                <a:cs typeface="Calibri" pitchFamily="34" charset="-120"/>
+              </a:rPr>
+              <a:t>4</a:t>
+            </a:r>
+            <a:endParaRPr lang="en-US" sz="1600" dirty="0"/>
+          </a:p>
+        </p:txBody>
+      </p:sp>
+      <p:sp>
+        <p:nvSpPr>
+          <p:cNvPr id="17" name="Text 15"/>
+          <p:cNvSpPr/>
+          <p:nvPr/>
+        </p:nvSpPr>
+        <p:spPr>
+          <a:xfrm>
+            <a:off x="1097280" y="3511296"/>
+            <a:ext cx="7315200" cy="365760"/>
           </a:xfrm>
           <a:prstGeom prst="rect">
             <a:avLst/>
@@ -6019,17 +7027,56 @@
               <a:buNone/>
             </a:pPr>
             <a:r>
-              <a:rPr lang="en-US" sz="1600" i="1" dirty="0">
-                <a:solidFill>
-                  <a:srgbClr val="FFFFFF"/>
-                </a:solidFill>
-                <a:latin typeface="Cambria" pitchFamily="34" charset="0"/>
-                <a:ea typeface="Cambria" pitchFamily="34" charset="-122"/>
-                <a:cs typeface="Cambria" pitchFamily="34" charset="-120"/>
-              </a:rPr>
-              <a:t>Пілот: підключити до реальної тікет-системи одного SaaS для закладів</a:t>
-            </a:r>
-            <a:endParaRPr lang="en-US" sz="1600" dirty="0"/>
+              <a:rPr lang="en-US" sz="1800" b="1" dirty="0">
+                <a:solidFill>
+                  <a:srgbClr val="F2A541"/>
+                </a:solidFill>
+                <a:latin typeface="Calibri" pitchFamily="34" charset="0"/>
+                <a:ea typeface="Calibri" pitchFamily="34" charset="-122"/>
+                <a:cs typeface="Calibri" pitchFamily="34" charset="-120"/>
+              </a:rPr>
+              <a:t>Емоційний тон</a:t>
+            </a:r>
+            <a:endParaRPr lang="en-US" sz="1800" dirty="0"/>
+          </a:p>
+        </p:txBody>
+      </p:sp>
+      <p:sp>
+        <p:nvSpPr>
+          <p:cNvPr id="18" name="Text 16"/>
+          <p:cNvSpPr/>
+          <p:nvPr/>
+        </p:nvSpPr>
+        <p:spPr>
+          <a:xfrm>
+            <a:off x="1097280" y="3895344"/>
+            <a:ext cx="7315200" cy="365760"/>
+          </a:xfrm>
+          <a:prstGeom prst="rect">
+            <a:avLst/>
+          </a:prstGeom>
+          <a:noFill/>
+          <a:ln/>
+        </p:spPr>
+        <p:txBody>
+          <a:bodyPr wrap="square" lIns="0" tIns="0" rIns="0" bIns="0" rtlCol="0" anchor="ctr"/>
+          <a:lstStyle/>
+          <a:p>
+            <a:pPr indent="0" marL="0">
+              <a:buNone/>
+            </a:pPr>
+            <a:r>
+              <a:rPr lang="en-US" sz="1300" dirty="0">
+                <a:solidFill>
+                  <a:srgbClr val="D5DBE8"/>
+                </a:solidFill>
+                <a:latin typeface="Calibri" pitchFamily="34" charset="0"/>
+                <a:ea typeface="Calibri" pitchFamily="34" charset="-122"/>
+                <a:cs typeface="Calibri" pitchFamily="34" charset="-120"/>
+              </a:rPr>
+              <a:t>Роздратований клієнт отримує пріоритет і спокійну відповідь з планом</a:t>
+            </a:r>
+            <a:endParaRPr lang="en-US" sz="1300" dirty="0"/>
           </a:p>
         </p:txBody>
       </p:sp>

</xml_diff>